<commit_message>
Add README assets and slides, remove stray root files
</commit_message>
<xml_diff>
--- a/slides/Results_Group_9.pptx
+++ b/slides/Results_Group_9.pptx
@@ -4,9 +4,6 @@
   <p:sldMasterIdLst>
     <p:sldMasterId id="2147483648" r:id="rId1"/>
   </p:sldMasterIdLst>
-  <p:notesMasterIdLst>
-    <p:notesMasterId r:id="rId17"/>
-  </p:notesMasterIdLst>
   <p:sldIdLst>
     <p:sldId id="256" r:id="rId2"/>
     <p:sldId id="257" r:id="rId3"/>
@@ -24,8 +21,11 @@
     <p:sldId id="269" r:id="rId15"/>
     <p:sldId id="270" r:id="rId16"/>
   </p:sldIdLst>
-  <p:sldSz cx="12192000" cy="6858000"/>
-  <p:notesSz cx="6858000" cy="12192000"/>
+  <p:notesMasterIdLst>
+    <p:notesMasterId r:id="rId17"/>
+  </p:notesMasterIdLst>
+  <p:sldSz cx="12191695" cy="6858000"/>
+  <p:notesSz cx="6858000" cy="12191695"/>
   <p:defaultTextStyle>
     <a:lvl1pPr marL="0" algn="l" defTabSz="914400" rtl="0" eaLnBrk="1" latinLnBrk="0" hangingPunct="1">
       <a:defRPr sz="1800" kern="1200">
@@ -118,11 +118,6 @@
       </a:defRPr>
     </a:lvl9pPr>
   </p:defaultTextStyle>
-  <p:extLst>
-    <p:ext uri="{EFAFB233-063F-42B5-8137-9DF3F51BA10A}">
-      <p15:sldGuideLst xmlns:p15="http://schemas.microsoft.com/office/powerpoint/2012/main"/>
-    </p:ext>
-  </p:extLst>
 </p:presentation>
 </file>
 
@@ -148,10 +143,234 @@
           <a:chExt cx="0" cy="0"/>
         </a:xfrm>
       </p:grpSpPr>
+      <p:sp>
+        <p:nvSpPr>
+          <p:cNvPr id="2" name="Header Placeholder 1"/>
+          <p:cNvSpPr>
+            <a:spLocks noGrp="1"/>
+          </p:cNvSpPr>
+          <p:nvPr>
+            <p:ph type="hdr" sz="quarter"/>
+          </p:nvPr>
+        </p:nvSpPr>
+        <p:spPr>
+          <a:xfrm>
+            <a:off x="0" y="0"/>
+            <a:ext cx="2971800" cy="458788"/>
+          </a:xfrm>
+          <a:prstGeom prst="rect">
+            <a:avLst/>
+          </a:prstGeom>
+        </p:spPr>
+        <p:txBody>
+          <a:bodyPr vert="horz" lIns="91440" tIns="45720" rIns="91440" bIns="45720" rtlCol="0"/>
+          <a:lstStyle>
+            <a:lvl1pPr algn="l">
+              <a:defRPr sz="1200"/>
+            </a:lvl1pPr>
+          </a:lstStyle>
+          <a:p>
+            <a:endParaRPr lang="en-US"/>
+          </a:p>
+        </p:txBody>
+      </p:sp>
+      <p:sp>
+        <p:nvSpPr>
+          <p:cNvPr id="3" name="Date Placeholder 2"/>
+          <p:cNvSpPr>
+            <a:spLocks noGrp="1"/>
+          </p:cNvSpPr>
+          <p:nvPr>
+            <p:ph type="dt" idx="1"/>
+          </p:nvPr>
+        </p:nvSpPr>
+        <p:spPr>
+          <a:xfrm>
+            <a:off x="3884613" y="0"/>
+            <a:ext cx="2971800" cy="458788"/>
+          </a:xfrm>
+          <a:prstGeom prst="rect">
+            <a:avLst/>
+          </a:prstGeom>
+        </p:spPr>
+        <p:txBody>
+          <a:bodyPr vert="horz" lIns="91440" tIns="45720" rIns="91440" bIns="45720" rtlCol="0"/>
+          <a:lstStyle>
+            <a:lvl1pPr algn="r">
+              <a:defRPr sz="1200"/>
+            </a:lvl1pPr>
+          </a:lstStyle>
+          <a:p>
+            <a:fld id="{5282F153-3F37-0F45-9E97-73ACFA13230C}" type="datetimeFigureOut">
+              <a:rPr lang="en-US"/>
+              <a:t>7/23/19</a:t>
+            </a:fld>
+            <a:endParaRPr lang="en-US"/>
+          </a:p>
+        </p:txBody>
+      </p:sp>
+      <p:sp>
+        <p:nvSpPr>
+          <p:cNvPr id="4" name="Slide Image Placeholder 3"/>
+          <p:cNvSpPr>
+            <a:spLocks noGrp="1" noRot="1" noChangeAspect="1"/>
+          </p:cNvSpPr>
+          <p:nvPr>
+            <p:ph type="sldImg" idx="2"/>
+          </p:nvPr>
+        </p:nvSpPr>
+        <p:spPr>
+          <a:xfrm>
+            <a:off x="685800" y="1143000"/>
+            <a:ext cx="5486400" cy="3086100"/>
+          </a:xfrm>
+          <a:prstGeom prst="rect">
+            <a:avLst/>
+          </a:prstGeom>
+          <a:noFill/>
+          <a:ln w="12700">
+            <a:solidFill>
+              <a:prstClr val="black"/>
+            </a:solidFill>
+          </a:ln>
+        </p:spPr>
+        <p:txBody>
+          <a:bodyPr vert="horz" lIns="91440" tIns="45720" rIns="91440" bIns="45720" rtlCol="0" anchor="ctr"/>
+          <a:lstStyle/>
+          <a:p>
+            <a:endParaRPr lang="en-US"/>
+          </a:p>
+        </p:txBody>
+      </p:sp>
+      <p:sp>
+        <p:nvSpPr>
+          <p:cNvPr id="5" name="Notes Placeholder 4"/>
+          <p:cNvSpPr>
+            <a:spLocks noGrp="1"/>
+          </p:cNvSpPr>
+          <p:nvPr>
+            <p:ph type="body" sz="quarter" idx="3"/>
+          </p:nvPr>
+        </p:nvSpPr>
+        <p:spPr>
+          <a:xfrm>
+            <a:off x="685800" y="4400550"/>
+            <a:ext cx="5486400" cy="3600450"/>
+          </a:xfrm>
+          <a:prstGeom prst="rect">
+            <a:avLst/>
+          </a:prstGeom>
+        </p:spPr>
+        <p:txBody>
+          <a:bodyPr vert="horz" lIns="91440" tIns="45720" rIns="91440" bIns="45720" rtlCol="0"/>
+          <a:lstStyle/>
+          <a:p>
+            <a:pPr lvl="0"/>
+            <a:r>
+              <a:rPr lang="en-US"/>
+              <a:t>Click to edit Master text styles</a:t>
+            </a:r>
+          </a:p>
+          <a:p>
+            <a:pPr lvl="1"/>
+            <a:r>
+              <a:rPr lang="en-US"/>
+              <a:t>Second level</a:t>
+            </a:r>
+          </a:p>
+          <a:p>
+            <a:pPr lvl="2"/>
+            <a:r>
+              <a:rPr lang="en-US"/>
+              <a:t>Third level</a:t>
+            </a:r>
+          </a:p>
+          <a:p>
+            <a:pPr lvl="3"/>
+            <a:r>
+              <a:rPr lang="en-US"/>
+              <a:t>Fourth level</a:t>
+            </a:r>
+          </a:p>
+          <a:p>
+            <a:pPr lvl="4"/>
+            <a:r>
+              <a:rPr lang="en-US"/>
+              <a:t>Fifth level</a:t>
+            </a:r>
+          </a:p>
+        </p:txBody>
+      </p:sp>
+      <p:sp>
+        <p:nvSpPr>
+          <p:cNvPr id="6" name="Footer Placeholder 5"/>
+          <p:cNvSpPr>
+            <a:spLocks noGrp="1"/>
+          </p:cNvSpPr>
+          <p:nvPr>
+            <p:ph type="ftr" sz="quarter" idx="4"/>
+          </p:nvPr>
+        </p:nvSpPr>
+        <p:spPr>
+          <a:xfrm>
+            <a:off x="0" y="8685213"/>
+            <a:ext cx="2971800" cy="458787"/>
+          </a:xfrm>
+          <a:prstGeom prst="rect">
+            <a:avLst/>
+          </a:prstGeom>
+        </p:spPr>
+        <p:txBody>
+          <a:bodyPr vert="horz" lIns="91440" tIns="45720" rIns="91440" bIns="45720" rtlCol="0" anchor="b"/>
+          <a:lstStyle>
+            <a:lvl1pPr algn="l">
+              <a:defRPr sz="1200"/>
+            </a:lvl1pPr>
+          </a:lstStyle>
+          <a:p>
+            <a:endParaRPr lang="en-US"/>
+          </a:p>
+        </p:txBody>
+      </p:sp>
+      <p:sp>
+        <p:nvSpPr>
+          <p:cNvPr id="7" name="Slide Number Placeholder 6"/>
+          <p:cNvSpPr>
+            <a:spLocks noGrp="1"/>
+          </p:cNvSpPr>
+          <p:nvPr>
+            <p:ph type="sldNum" sz="quarter" idx="5"/>
+          </p:nvPr>
+        </p:nvSpPr>
+        <p:spPr>
+          <a:xfrm>
+            <a:off x="3884613" y="8685213"/>
+            <a:ext cx="2971800" cy="458787"/>
+          </a:xfrm>
+          <a:prstGeom prst="rect">
+            <a:avLst/>
+          </a:prstGeom>
+        </p:spPr>
+        <p:txBody>
+          <a:bodyPr vert="horz" lIns="91440" tIns="45720" rIns="91440" bIns="45720" rtlCol="0" anchor="b"/>
+          <a:lstStyle>
+            <a:lvl1pPr algn="r">
+              <a:defRPr sz="1200"/>
+            </a:lvl1pPr>
+          </a:lstStyle>
+          <a:p>
+            <a:fld id="{CE5E9CC1-C706-0F49-92D6-E571CC5EEA8F}" type="slidenum">
+              <a:rPr lang="en-US"/>
+              <a:t>‹#›</a:t>
+            </a:fld>
+            <a:endParaRPr lang="en-US"/>
+          </a:p>
+        </p:txBody>
+      </p:sp>
     </p:spTree>
     <p:extLst>
       <p:ext uri="{BB962C8B-B14F-4D97-AF65-F5344CB8AC3E}">
-        <p14:creationId xmlns:p14="http://schemas.microsoft.com/office/powerpoint/2010/main" val="1956736038"/>
+        <p14:creationId xmlns:p14="http://schemas.microsoft.com/office/powerpoint/2010/main" val="1024086991"/>
       </p:ext>
     </p:extLst>
   </p:cSld>
@@ -295,6 +514,10 @@
           <a:bodyPr/>
           <a:lstStyle/>
           <a:p>
+            <a:r>
+              <a:rPr lang="en-US" dirty="0"/>
+              <a:t/>
+            </a:r>
             <a:endParaRPr lang="en-US" dirty="0"/>
           </a:p>
         </p:txBody>
@@ -379,6 +602,10 @@
           <a:bodyPr/>
           <a:lstStyle/>
           <a:p>
+            <a:r>
+              <a:rPr lang="en-US" dirty="0"/>
+              <a:t/>
+            </a:r>
             <a:endParaRPr lang="en-US" dirty="0"/>
           </a:p>
         </p:txBody>
@@ -463,6 +690,10 @@
           <a:bodyPr/>
           <a:lstStyle/>
           <a:p>
+            <a:r>
+              <a:rPr lang="en-US" dirty="0"/>
+              <a:t/>
+            </a:r>
             <a:endParaRPr lang="en-US" dirty="0"/>
           </a:p>
         </p:txBody>
@@ -547,6 +778,10 @@
           <a:bodyPr/>
           <a:lstStyle/>
           <a:p>
+            <a:r>
+              <a:rPr lang="en-US" dirty="0"/>
+              <a:t/>
+            </a:r>
             <a:endParaRPr lang="en-US" dirty="0"/>
           </a:p>
         </p:txBody>
@@ -631,6 +866,10 @@
           <a:bodyPr/>
           <a:lstStyle/>
           <a:p>
+            <a:r>
+              <a:rPr lang="en-US" dirty="0"/>
+              <a:t/>
+            </a:r>
             <a:endParaRPr lang="en-US" dirty="0"/>
           </a:p>
         </p:txBody>
@@ -715,6 +954,10 @@
           <a:bodyPr/>
           <a:lstStyle/>
           <a:p>
+            <a:r>
+              <a:rPr lang="en-US" dirty="0"/>
+              <a:t/>
+            </a:r>
             <a:endParaRPr lang="en-US" dirty="0"/>
           </a:p>
         </p:txBody>
@@ -799,6 +1042,10 @@
           <a:bodyPr/>
           <a:lstStyle/>
           <a:p>
+            <a:r>
+              <a:rPr lang="en-US" dirty="0"/>
+              <a:t/>
+            </a:r>
             <a:endParaRPr lang="en-US" dirty="0"/>
           </a:p>
         </p:txBody>
@@ -883,6 +1130,10 @@
           <a:bodyPr/>
           <a:lstStyle/>
           <a:p>
+            <a:r>
+              <a:rPr lang="en-US" dirty="0"/>
+              <a:t/>
+            </a:r>
             <a:endParaRPr lang="en-US" dirty="0"/>
           </a:p>
         </p:txBody>
@@ -967,6 +1218,10 @@
           <a:bodyPr/>
           <a:lstStyle/>
           <a:p>
+            <a:r>
+              <a:rPr lang="en-US" dirty="0"/>
+              <a:t/>
+            </a:r>
             <a:endParaRPr lang="en-US" dirty="0"/>
           </a:p>
         </p:txBody>
@@ -1051,6 +1306,10 @@
           <a:bodyPr/>
           <a:lstStyle/>
           <a:p>
+            <a:r>
+              <a:rPr lang="en-US" dirty="0"/>
+              <a:t/>
+            </a:r>
             <a:endParaRPr lang="en-US" dirty="0"/>
           </a:p>
         </p:txBody>
@@ -1135,6 +1394,10 @@
           <a:bodyPr/>
           <a:lstStyle/>
           <a:p>
+            <a:r>
+              <a:rPr lang="en-US" dirty="0"/>
+              <a:t/>
+            </a:r>
             <a:endParaRPr lang="en-US" dirty="0"/>
           </a:p>
         </p:txBody>
@@ -1219,6 +1482,10 @@
           <a:bodyPr/>
           <a:lstStyle/>
           <a:p>
+            <a:r>
+              <a:rPr lang="en-US" dirty="0"/>
+              <a:t/>
+            </a:r>
             <a:endParaRPr lang="en-US" dirty="0"/>
           </a:p>
         </p:txBody>
@@ -1303,6 +1570,10 @@
           <a:bodyPr/>
           <a:lstStyle/>
           <a:p>
+            <a:r>
+              <a:rPr lang="en-US" dirty="0"/>
+              <a:t/>
+            </a:r>
             <a:endParaRPr lang="en-US" dirty="0"/>
           </a:p>
         </p:txBody>
@@ -1387,6 +1658,10 @@
           <a:bodyPr/>
           <a:lstStyle/>
           <a:p>
+            <a:r>
+              <a:rPr lang="en-US" dirty="0"/>
+              <a:t/>
+            </a:r>
             <a:endParaRPr lang="en-US" dirty="0"/>
           </a:p>
         </p:txBody>
@@ -1471,6 +1746,10 @@
           <a:bodyPr/>
           <a:lstStyle/>
           <a:p>
+            <a:r>
+              <a:rPr lang="en-US" dirty="0"/>
+              <a:t/>
+            </a:r>
             <a:endParaRPr lang="en-US" dirty="0"/>
           </a:p>
         </p:txBody>
@@ -1544,11 +1823,6 @@
 <file path=ppt/slideMasters/slideMaster1.xml><?xml version="1.0" encoding="utf-8"?>
 <p:sldMaster xmlns:a="http://schemas.openxmlformats.org/drawingml/2006/main" xmlns:r="http://schemas.openxmlformats.org/officeDocument/2006/relationships" xmlns:p="http://schemas.openxmlformats.org/presentationml/2006/main">
   <p:cSld>
-    <p:bg>
-      <p:bgRef idx="1001">
-        <a:schemeClr val="bg1"/>
-      </p:bgRef>
-    </p:bg>
     <p:spTree>
       <p:nvGrpSpPr>
         <p:cNvPr id="1" name=""/>
@@ -1831,7 +2105,6 @@
         <a:solidFill>
           <a:srgbClr val="FFFFFF"/>
         </a:solidFill>
-        <a:effectLst/>
       </p:bgPr>
     </p:bg>
     <p:spTree>
@@ -1869,11 +2142,11 @@
           <a:bodyPr wrap="square" rtlCol="0" anchor="ctr"/>
           <a:lstStyle/>
           <a:p>
-            <a:pPr marL="0" indent="0">
-              <a:buNone/>
-            </a:pPr>
-            <a:r>
-              <a:rPr lang="en-US" sz="1300" b="1" kern="0" spc="300" dirty="0">
+            <a:pPr indent="0" marL="0">
+              <a:buNone/>
+            </a:pPr>
+            <a:r>
+              <a:rPr lang="en-US" sz="1300" b="1" spc="300" kern="0" dirty="0">
                 <a:solidFill>
                   <a:srgbClr val="B02621"/>
                 </a:solidFill>
@@ -1908,7 +2181,7 @@
           <a:bodyPr wrap="square" rtlCol="0" anchor="ctr"/>
           <a:lstStyle/>
           <a:p>
-            <a:pPr marL="0" indent="0">
+            <a:pPr indent="0" marL="0">
               <a:buNone/>
             </a:pPr>
             <a:r>
@@ -1947,7 +2220,7 @@
           <a:bodyPr wrap="square" rtlCol="0" anchor="ctr"/>
           <a:lstStyle/>
           <a:p>
-            <a:pPr marL="0" indent="0">
+            <a:pPr indent="0" marL="0">
               <a:buNone/>
             </a:pPr>
             <a:r>
@@ -1986,7 +2259,7 @@
           <a:bodyPr wrap="square" rtlCol="0" anchor="ctr"/>
           <a:lstStyle/>
           <a:p>
-            <a:pPr marL="0" indent="0" algn="r">
+            <a:pPr algn="r" indent="0" marL="0">
               <a:buNone/>
             </a:pPr>
             <a:r>
@@ -2025,7 +2298,7 @@
           <a:bodyPr wrap="square" rtlCol="0" anchor="t"/>
           <a:lstStyle/>
           <a:p>
-            <a:pPr marL="0" indent="0">
+            <a:pPr indent="0" marL="0">
               <a:lnSpc>
                 <a:spcPct val="108000"/>
               </a:lnSpc>
@@ -2048,7 +2321,7 @@
             <a:endParaRPr lang="en-US" sz="1350" dirty="0"/>
           </a:p>
           <a:p>
-            <a:pPr marL="0" indent="0">
+            <a:pPr indent="0" marL="0">
               <a:lnSpc>
                 <a:spcPct val="108000"/>
               </a:lnSpc>
@@ -2071,7 +2344,7 @@
             <a:endParaRPr lang="en-US" sz="1350" dirty="0"/>
           </a:p>
           <a:p>
-            <a:pPr marL="0" indent="0">
+            <a:pPr indent="0" marL="0">
               <a:lnSpc>
                 <a:spcPct val="108000"/>
               </a:lnSpc>
@@ -2097,14 +2370,14 @@
       </p:sp>
       <p:pic>
         <p:nvPicPr>
-          <p:cNvPr id="7" name="Image 0" descr="figs/fig1_auroc.png"/>
+          <p:cNvPr id="7" name="Image 0" descr="figs/fig1_auroc.png">    </p:cNvPr>
           <p:cNvPicPr>
             <a:picLocks noChangeAspect="1"/>
           </p:cNvPicPr>
           <p:nvPr/>
         </p:nvPicPr>
         <p:blipFill>
-          <a:blip r:embed="rId3"/>
+          <a:blip r:embed="rId1"/>
           <a:stretch>
             <a:fillRect/>
           </a:stretch>
@@ -2135,7 +2408,6 @@
         <a:solidFill>
           <a:srgbClr val="FFFFFF"/>
         </a:solidFill>
-        <a:effectLst/>
       </p:bgPr>
     </p:bg>
     <p:spTree>
@@ -2173,11 +2445,11 @@
           <a:bodyPr wrap="square" rtlCol="0" anchor="ctr"/>
           <a:lstStyle/>
           <a:p>
-            <a:pPr marL="0" indent="0">
-              <a:buNone/>
-            </a:pPr>
-            <a:r>
-              <a:rPr lang="en-US" sz="1300" b="1" kern="0" spc="300" dirty="0">
+            <a:pPr indent="0" marL="0">
+              <a:buNone/>
+            </a:pPr>
+            <a:r>
+              <a:rPr lang="en-US" sz="1300" b="1" spc="300" kern="0" dirty="0">
                 <a:solidFill>
                   <a:srgbClr val="B02621"/>
                 </a:solidFill>
@@ -2212,7 +2484,7 @@
           <a:bodyPr wrap="square" rtlCol="0" anchor="ctr"/>
           <a:lstStyle/>
           <a:p>
-            <a:pPr marL="0" indent="0">
+            <a:pPr indent="0" marL="0">
               <a:buNone/>
             </a:pPr>
             <a:r>
@@ -2251,7 +2523,7 @@
           <a:bodyPr wrap="square" rtlCol="0" anchor="ctr"/>
           <a:lstStyle/>
           <a:p>
-            <a:pPr marL="0" indent="0">
+            <a:pPr indent="0" marL="0">
               <a:buNone/>
             </a:pPr>
             <a:r>
@@ -2290,7 +2562,7 @@
           <a:bodyPr wrap="square" rtlCol="0" anchor="ctr"/>
           <a:lstStyle/>
           <a:p>
-            <a:pPr marL="0" indent="0" algn="r">
+            <a:pPr algn="r" indent="0" marL="0">
               <a:buNone/>
             </a:pPr>
             <a:r>
@@ -2329,7 +2601,7 @@
           <a:bodyPr wrap="square" rtlCol="0" anchor="t"/>
           <a:lstStyle/>
           <a:p>
-            <a:pPr marL="0" indent="0">
+            <a:pPr indent="0" marL="0">
               <a:lnSpc>
                 <a:spcPct val="108000"/>
               </a:lnSpc>
@@ -2352,7 +2624,7 @@
             <a:endParaRPr lang="en-US" sz="1850" dirty="0"/>
           </a:p>
           <a:p>
-            <a:pPr marL="0" indent="0">
+            <a:pPr indent="0" marL="0">
               <a:lnSpc>
                 <a:spcPct val="108000"/>
               </a:lnSpc>
@@ -2375,7 +2647,7 @@
             <a:endParaRPr lang="en-US" sz="1850" dirty="0"/>
           </a:p>
           <a:p>
-            <a:pPr marL="0" indent="0">
+            <a:pPr indent="0" marL="0">
               <a:lnSpc>
                 <a:spcPct val="108000"/>
               </a:lnSpc>
@@ -2401,14 +2673,14 @@
       </p:sp>
       <p:pic>
         <p:nvPicPr>
-          <p:cNvPr id="7" name="Image 0" descr="figs/fig5_armrec.png"/>
+          <p:cNvPr id="7" name="Image 0" descr="figs/fig5_armrec.png">    </p:cNvPr>
           <p:cNvPicPr>
             <a:picLocks noChangeAspect="1"/>
           </p:cNvPicPr>
           <p:nvPr/>
         </p:nvPicPr>
         <p:blipFill>
-          <a:blip r:embed="rId3"/>
+          <a:blip r:embed="rId1"/>
           <a:stretch>
             <a:fillRect/>
           </a:stretch>
@@ -2439,7 +2711,6 @@
         <a:solidFill>
           <a:srgbClr val="FFFFFF"/>
         </a:solidFill>
-        <a:effectLst/>
       </p:bgPr>
     </p:bg>
     <p:spTree>
@@ -2477,11 +2748,11 @@
           <a:bodyPr wrap="square" rtlCol="0" anchor="ctr"/>
           <a:lstStyle/>
           <a:p>
-            <a:pPr marL="0" indent="0">
-              <a:buNone/>
-            </a:pPr>
-            <a:r>
-              <a:rPr lang="en-US" sz="1300" b="1" kern="0" spc="300" dirty="0">
+            <a:pPr indent="0" marL="0">
+              <a:buNone/>
+            </a:pPr>
+            <a:r>
+              <a:rPr lang="en-US" sz="1300" b="1" spc="300" kern="0" dirty="0">
                 <a:solidFill>
                   <a:srgbClr val="B02621"/>
                 </a:solidFill>
@@ -2516,7 +2787,7 @@
           <a:bodyPr wrap="square" rtlCol="0" anchor="ctr"/>
           <a:lstStyle/>
           <a:p>
-            <a:pPr marL="0" indent="0">
+            <a:pPr indent="0" marL="0">
               <a:buNone/>
             </a:pPr>
             <a:r>
@@ -2555,7 +2826,7 @@
           <a:bodyPr wrap="square" rtlCol="0" anchor="ctr"/>
           <a:lstStyle/>
           <a:p>
-            <a:pPr marL="0" indent="0">
+            <a:pPr indent="0" marL="0">
               <a:buNone/>
             </a:pPr>
             <a:r>
@@ -2594,7 +2865,7 @@
           <a:bodyPr wrap="square" rtlCol="0" anchor="ctr"/>
           <a:lstStyle/>
           <a:p>
-            <a:pPr marL="0" indent="0" algn="r">
+            <a:pPr algn="r" indent="0" marL="0">
               <a:buNone/>
             </a:pPr>
             <a:r>
@@ -2633,7 +2904,7 @@
           <a:bodyPr wrap="square" rtlCol="0" anchor="t"/>
           <a:lstStyle/>
           <a:p>
-            <a:pPr marL="0" indent="0">
+            <a:pPr indent="0" marL="0">
               <a:lnSpc>
                 <a:spcPct val="108000"/>
               </a:lnSpc>
@@ -2656,7 +2927,7 @@
             <a:endParaRPr lang="en-US" sz="1850" dirty="0"/>
           </a:p>
           <a:p>
-            <a:pPr marL="0" indent="0">
+            <a:pPr indent="0" marL="0">
               <a:lnSpc>
                 <a:spcPct val="108000"/>
               </a:lnSpc>
@@ -2679,7 +2950,7 @@
             <a:endParaRPr lang="en-US" sz="1850" dirty="0"/>
           </a:p>
           <a:p>
-            <a:pPr marL="0" indent="0">
+            <a:pPr indent="0" marL="0">
               <a:lnSpc>
                 <a:spcPct val="108000"/>
               </a:lnSpc>
@@ -2705,14 +2976,14 @@
       </p:sp>
       <p:pic>
         <p:nvPicPr>
-          <p:cNvPr id="7" name="Image 0" descr="figs/fig6_loh.png"/>
+          <p:cNvPr id="7" name="Image 0" descr="figs/fig6_loh.png">    </p:cNvPr>
           <p:cNvPicPr>
             <a:picLocks noChangeAspect="1"/>
           </p:cNvPicPr>
           <p:nvPr/>
         </p:nvPicPr>
         <p:blipFill>
-          <a:blip r:embed="rId3"/>
+          <a:blip r:embed="rId1"/>
           <a:stretch>
             <a:fillRect/>
           </a:stretch>
@@ -2743,7 +3014,6 @@
         <a:solidFill>
           <a:srgbClr val="FFFFFF"/>
         </a:solidFill>
-        <a:effectLst/>
       </p:bgPr>
     </p:bg>
     <p:spTree>
@@ -2781,11 +3051,11 @@
           <a:bodyPr wrap="square" rtlCol="0" anchor="ctr"/>
           <a:lstStyle/>
           <a:p>
-            <a:pPr marL="0" indent="0">
-              <a:buNone/>
-            </a:pPr>
-            <a:r>
-              <a:rPr lang="en-US" sz="1300" b="1" kern="0" spc="300" dirty="0">
+            <a:pPr indent="0" marL="0">
+              <a:buNone/>
+            </a:pPr>
+            <a:r>
+              <a:rPr lang="en-US" sz="1300" b="1" spc="300" kern="0" dirty="0">
                 <a:solidFill>
                   <a:srgbClr val="B02621"/>
                 </a:solidFill>
@@ -2820,7 +3090,7 @@
           <a:bodyPr wrap="square" rtlCol="0" anchor="ctr"/>
           <a:lstStyle/>
           <a:p>
-            <a:pPr marL="0" indent="0">
+            <a:pPr indent="0" marL="0">
               <a:buNone/>
             </a:pPr>
             <a:r>
@@ -2859,7 +3129,7 @@
           <a:bodyPr wrap="square" rtlCol="0" anchor="ctr"/>
           <a:lstStyle/>
           <a:p>
-            <a:pPr marL="0" indent="0">
+            <a:pPr indent="0" marL="0">
               <a:buNone/>
             </a:pPr>
             <a:r>
@@ -2898,7 +3168,7 @@
           <a:bodyPr wrap="square" rtlCol="0" anchor="ctr"/>
           <a:lstStyle/>
           <a:p>
-            <a:pPr marL="0" indent="0" algn="r">
+            <a:pPr algn="r" indent="0" marL="0">
               <a:buNone/>
             </a:pPr>
             <a:r>
@@ -2937,7 +3207,7 @@
           <a:bodyPr wrap="square" rtlCol="0" anchor="t"/>
           <a:lstStyle/>
           <a:p>
-            <a:pPr marL="0" indent="0">
+            <a:pPr indent="0" marL="0">
               <a:lnSpc>
                 <a:spcPct val="108000"/>
               </a:lnSpc>
@@ -2960,7 +3230,7 @@
             <a:endParaRPr lang="en-US" sz="1850" dirty="0"/>
           </a:p>
           <a:p>
-            <a:pPr marL="0" indent="0">
+            <a:pPr indent="0" marL="0">
               <a:lnSpc>
                 <a:spcPct val="108000"/>
               </a:lnSpc>
@@ -2983,7 +3253,7 @@
             <a:endParaRPr lang="en-US" sz="1850" dirty="0"/>
           </a:p>
           <a:p>
-            <a:pPr marL="0" indent="0">
+            <a:pPr indent="0" marL="0">
               <a:lnSpc>
                 <a:spcPct val="108000"/>
               </a:lnSpc>
@@ -3009,14 +3279,14 @@
       </p:sp>
       <p:pic>
         <p:nvPicPr>
-          <p:cNvPr id="7" name="Image 0" descr="figs/figARM_arms.png"/>
+          <p:cNvPr id="7" name="Image 0" descr="figs/figARM_arms.png">    </p:cNvPr>
           <p:cNvPicPr>
             <a:picLocks noChangeAspect="1"/>
           </p:cNvPicPr>
           <p:nvPr/>
         </p:nvPicPr>
         <p:blipFill>
-          <a:blip r:embed="rId3"/>
+          <a:blip r:embed="rId1"/>
           <a:stretch>
             <a:fillRect/>
           </a:stretch>
@@ -3047,7 +3317,6 @@
         <a:solidFill>
           <a:srgbClr val="FFFFFF"/>
         </a:solidFill>
-        <a:effectLst/>
       </p:bgPr>
     </p:bg>
     <p:spTree>
@@ -3085,11 +3354,11 @@
           <a:bodyPr wrap="square" rtlCol="0" anchor="ctr"/>
           <a:lstStyle/>
           <a:p>
-            <a:pPr marL="0" indent="0">
-              <a:buNone/>
-            </a:pPr>
-            <a:r>
-              <a:rPr lang="en-US" sz="1300" b="1" kern="0" spc="300" dirty="0">
+            <a:pPr indent="0" marL="0">
+              <a:buNone/>
+            </a:pPr>
+            <a:r>
+              <a:rPr lang="en-US" sz="1300" b="1" spc="300" kern="0" dirty="0">
                 <a:solidFill>
                   <a:srgbClr val="B02621"/>
                 </a:solidFill>
@@ -3124,7 +3393,7 @@
           <a:bodyPr wrap="square" rtlCol="0" anchor="ctr"/>
           <a:lstStyle/>
           <a:p>
-            <a:pPr marL="0" indent="0">
+            <a:pPr indent="0" marL="0">
               <a:buNone/>
             </a:pPr>
             <a:r>
@@ -3163,7 +3432,7 @@
           <a:bodyPr wrap="square" rtlCol="0" anchor="ctr"/>
           <a:lstStyle/>
           <a:p>
-            <a:pPr marL="0" indent="0">
+            <a:pPr indent="0" marL="0">
               <a:buNone/>
             </a:pPr>
             <a:r>
@@ -3202,7 +3471,7 @@
           <a:bodyPr wrap="square" rtlCol="0" anchor="ctr"/>
           <a:lstStyle/>
           <a:p>
-            <a:pPr marL="0" indent="0" algn="r">
+            <a:pPr algn="r" indent="0" marL="0">
               <a:buNone/>
             </a:pPr>
             <a:r>
@@ -3241,7 +3510,7 @@
           <a:bodyPr wrap="square" rtlCol="0" anchor="t"/>
           <a:lstStyle/>
           <a:p>
-            <a:pPr marL="0" indent="0">
+            <a:pPr indent="0" marL="0">
               <a:lnSpc>
                 <a:spcPct val="108000"/>
               </a:lnSpc>
@@ -3264,7 +3533,7 @@
             <a:endParaRPr lang="en-US" sz="1850" dirty="0"/>
           </a:p>
           <a:p>
-            <a:pPr marL="0" indent="0">
+            <a:pPr indent="0" marL="0">
               <a:lnSpc>
                 <a:spcPct val="108000"/>
               </a:lnSpc>
@@ -3287,7 +3556,7 @@
             <a:endParaRPr lang="en-US" sz="1850" dirty="0"/>
           </a:p>
           <a:p>
-            <a:pPr marL="0" indent="0">
+            <a:pPr indent="0" marL="0">
               <a:lnSpc>
                 <a:spcPct val="108000"/>
               </a:lnSpc>
@@ -3313,14 +3582,14 @@
       </p:sp>
       <p:pic>
         <p:nvPicPr>
-          <p:cNvPr id="7" name="Image 0" descr="figs/fig7_controls.png"/>
+          <p:cNvPr id="7" name="Image 0" descr="figs/fig7_controls.png">    </p:cNvPr>
           <p:cNvPicPr>
             <a:picLocks noChangeAspect="1"/>
           </p:cNvPicPr>
           <p:nvPr/>
         </p:nvPicPr>
         <p:blipFill>
-          <a:blip r:embed="rId3"/>
+          <a:blip r:embed="rId1"/>
           <a:stretch>
             <a:fillRect/>
           </a:stretch>
@@ -3351,7 +3620,6 @@
         <a:solidFill>
           <a:srgbClr val="FFFFFF"/>
         </a:solidFill>
-        <a:effectLst/>
       </p:bgPr>
     </p:bg>
     <p:spTree>
@@ -3389,11 +3657,11 @@
           <a:bodyPr wrap="square" rtlCol="0" anchor="ctr"/>
           <a:lstStyle/>
           <a:p>
-            <a:pPr marL="0" indent="0">
-              <a:buNone/>
-            </a:pPr>
-            <a:r>
-              <a:rPr lang="en-US" sz="1300" b="1" kern="0" spc="300" dirty="0">
+            <a:pPr indent="0" marL="0">
+              <a:buNone/>
+            </a:pPr>
+            <a:r>
+              <a:rPr lang="en-US" sz="1300" b="1" spc="300" kern="0" dirty="0">
                 <a:solidFill>
                   <a:srgbClr val="B02621"/>
                 </a:solidFill>
@@ -3428,7 +3696,7 @@
           <a:bodyPr wrap="square" rtlCol="0" anchor="ctr"/>
           <a:lstStyle/>
           <a:p>
-            <a:pPr marL="0" indent="0">
+            <a:pPr indent="0" marL="0">
               <a:buNone/>
             </a:pPr>
             <a:r>
@@ -3467,7 +3735,7 @@
           <a:bodyPr wrap="square" rtlCol="0" anchor="ctr"/>
           <a:lstStyle/>
           <a:p>
-            <a:pPr marL="0" indent="0">
+            <a:pPr indent="0" marL="0">
               <a:buNone/>
             </a:pPr>
             <a:r>
@@ -3506,7 +3774,7 @@
           <a:bodyPr wrap="square" rtlCol="0" anchor="ctr"/>
           <a:lstStyle/>
           <a:p>
-            <a:pPr marL="0" indent="0" algn="r">
+            <a:pPr algn="r" indent="0" marL="0">
               <a:buNone/>
             </a:pPr>
             <a:r>
@@ -3545,7 +3813,7 @@
           <a:bodyPr wrap="square" rtlCol="0" anchor="t"/>
           <a:lstStyle/>
           <a:p>
-            <a:pPr marL="0" indent="0">
+            <a:pPr indent="0" marL="0">
               <a:lnSpc>
                 <a:spcPct val="108000"/>
               </a:lnSpc>
@@ -3568,7 +3836,7 @@
             <a:endParaRPr lang="en-US" sz="1850" dirty="0"/>
           </a:p>
           <a:p>
-            <a:pPr marL="0" indent="0">
+            <a:pPr indent="0" marL="0">
               <a:lnSpc>
                 <a:spcPct val="108000"/>
               </a:lnSpc>
@@ -3591,7 +3859,7 @@
             <a:endParaRPr lang="en-US" sz="1850" dirty="0"/>
           </a:p>
           <a:p>
-            <a:pPr marL="0" indent="0">
+            <a:pPr indent="0" marL="0">
               <a:lnSpc>
                 <a:spcPct val="108000"/>
               </a:lnSpc>
@@ -3617,14 +3885,14 @@
       </p:sp>
       <p:pic>
         <p:nvPicPr>
-          <p:cNvPr id="7" name="Image 0" descr="figs/figCTX_context.png"/>
+          <p:cNvPr id="7" name="Image 0" descr="figs/figCTX_context.png">    </p:cNvPr>
           <p:cNvPicPr>
             <a:picLocks noChangeAspect="1"/>
           </p:cNvPicPr>
           <p:nvPr/>
         </p:nvPicPr>
         <p:blipFill>
-          <a:blip r:embed="rId3"/>
+          <a:blip r:embed="rId1"/>
           <a:stretch>
             <a:fillRect/>
           </a:stretch>
@@ -3655,7 +3923,6 @@
         <a:solidFill>
           <a:srgbClr val="FFFFFF"/>
         </a:solidFill>
-        <a:effectLst/>
       </p:bgPr>
     </p:bg>
     <p:spTree>
@@ -3693,11 +3960,11 @@
           <a:bodyPr wrap="square" rtlCol="0" anchor="ctr"/>
           <a:lstStyle/>
           <a:p>
-            <a:pPr marL="0" indent="0">
-              <a:buNone/>
-            </a:pPr>
-            <a:r>
-              <a:rPr lang="en-US" sz="1300" b="1" kern="0" spc="300" dirty="0">
+            <a:pPr indent="0" marL="0">
+              <a:buNone/>
+            </a:pPr>
+            <a:r>
+              <a:rPr lang="en-US" sz="1300" b="1" spc="300" kern="0" dirty="0">
                 <a:solidFill>
                   <a:srgbClr val="B02621"/>
                 </a:solidFill>
@@ -3732,7 +3999,7 @@
           <a:bodyPr wrap="square" rtlCol="0" anchor="ctr"/>
           <a:lstStyle/>
           <a:p>
-            <a:pPr marL="0" indent="0">
+            <a:pPr indent="0" marL="0">
               <a:buNone/>
             </a:pPr>
             <a:r>
@@ -3771,7 +4038,7 @@
           <a:bodyPr wrap="square" rtlCol="0" anchor="ctr"/>
           <a:lstStyle/>
           <a:p>
-            <a:pPr marL="0" indent="0">
+            <a:pPr indent="0" marL="0">
               <a:buNone/>
             </a:pPr>
             <a:r>
@@ -3810,7 +4077,7 @@
           <a:bodyPr wrap="square" rtlCol="0" anchor="ctr"/>
           <a:lstStyle/>
           <a:p>
-            <a:pPr marL="0" indent="0" algn="r">
+            <a:pPr algn="r" indent="0" marL="0">
               <a:buNone/>
             </a:pPr>
             <a:r>
@@ -3844,41 +4111,17 @@
         </p:nvGraphicFramePr>
         <p:xfrm>
           <a:off x="640080" y="1417320"/>
-          <a:ext cx="10908792" cy="4572000"/>
+          <a:ext cx="10911535" cy="914400"/>
         </p:xfrm>
         <a:graphic>
           <a:graphicData uri="http://schemas.openxmlformats.org/drawingml/2006/table">
             <a:tbl>
               <a:tblPr/>
               <a:tblGrid>
-                <a:gridCol w="2514600">
-                  <a:extLst>
-                    <a:ext uri="{9D8B030D-6E8A-4147-A177-3AD203B41FA5}">
-                      <a16:colId xmlns:a16="http://schemas.microsoft.com/office/drawing/2014/main" val="20000"/>
-                    </a:ext>
-                  </a:extLst>
-                </a:gridCol>
-                <a:gridCol w="3246120">
-                  <a:extLst>
-                    <a:ext uri="{9D8B030D-6E8A-4147-A177-3AD203B41FA5}">
-                      <a16:colId xmlns:a16="http://schemas.microsoft.com/office/drawing/2014/main" val="20001"/>
-                    </a:ext>
-                  </a:extLst>
-                </a:gridCol>
-                <a:gridCol w="1554480">
-                  <a:extLst>
-                    <a:ext uri="{9D8B030D-6E8A-4147-A177-3AD203B41FA5}">
-                      <a16:colId xmlns:a16="http://schemas.microsoft.com/office/drawing/2014/main" val="20002"/>
-                    </a:ext>
-                  </a:extLst>
-                </a:gridCol>
-                <a:gridCol w="3593592">
-                  <a:extLst>
-                    <a:ext uri="{9D8B030D-6E8A-4147-A177-3AD203B41FA5}">
-                      <a16:colId xmlns:a16="http://schemas.microsoft.com/office/drawing/2014/main" val="20003"/>
-                    </a:ext>
-                  </a:extLst>
-                </a:gridCol>
+                <a:gridCol w="2514600"/>
+                <a:gridCol w="3246120"/>
+                <a:gridCol w="1554480"/>
+                <a:gridCol w="3593592"/>
               </a:tblGrid>
               <a:tr h="457200">
                 <a:tc>
@@ -3886,7 +4129,7 @@
                     <a:bodyPr/>
                     <a:lstStyle/>
                     <a:p>
-                      <a:pPr marL="0" indent="0">
+                      <a:pPr indent="0" marL="0">
                         <a:buNone/>
                       </a:pPr>
                       <a:r>
@@ -3954,7 +4197,7 @@
                     <a:bodyPr/>
                     <a:lstStyle/>
                     <a:p>
-                      <a:pPr marL="0" indent="0">
+                      <a:pPr indent="0" marL="0">
                         <a:buNone/>
                       </a:pPr>
                       <a:r>
@@ -4022,7 +4265,7 @@
                     <a:bodyPr/>
                     <a:lstStyle/>
                     <a:p>
-                      <a:pPr marL="0" indent="0">
+                      <a:pPr indent="0" marL="0">
                         <a:buNone/>
                       </a:pPr>
                       <a:r>
@@ -4090,7 +4333,7 @@
                     <a:bodyPr/>
                     <a:lstStyle/>
                     <a:p>
-                      <a:pPr marL="0" indent="0">
+                      <a:pPr indent="0" marL="0">
                         <a:buNone/>
                       </a:pPr>
                       <a:r>
@@ -4153,11 +4396,6 @@
                     </a:solidFill>
                   </a:tcPr>
                 </a:tc>
-                <a:extLst>
-                  <a:ext uri="{0D108BD9-81ED-4DB2-BD59-A6C34878D82A}">
-                    <a16:rowId xmlns:a16="http://schemas.microsoft.com/office/drawing/2014/main" val="10000"/>
-                  </a:ext>
-                </a:extLst>
               </a:tr>
               <a:tr h="457200">
                 <a:tc>
@@ -4165,7 +4403,7 @@
                     <a:bodyPr/>
                     <a:lstStyle/>
                     <a:p>
-                      <a:pPr marL="0" indent="0">
+                      <a:pPr indent="0" marL="0">
                         <a:buNone/>
                       </a:pPr>
                       <a:r>
@@ -4233,7 +4471,7 @@
                     <a:bodyPr/>
                     <a:lstStyle/>
                     <a:p>
-                      <a:pPr marL="0" indent="0">
+                      <a:pPr indent="0" marL="0">
                         <a:buNone/>
                       </a:pPr>
                       <a:r>
@@ -4301,7 +4539,7 @@
                     <a:bodyPr/>
                     <a:lstStyle/>
                     <a:p>
-                      <a:pPr marL="0" indent="0">
+                      <a:pPr indent="0" marL="0">
                         <a:buNone/>
                       </a:pPr>
                       <a:r>
@@ -4369,7 +4607,7 @@
                     <a:bodyPr/>
                     <a:lstStyle/>
                     <a:p>
-                      <a:pPr marL="0" indent="0">
+                      <a:pPr indent="0" marL="0">
                         <a:buNone/>
                       </a:pPr>
                       <a:r>
@@ -4432,11 +4670,6 @@
                     </a:solidFill>
                   </a:tcPr>
                 </a:tc>
-                <a:extLst>
-                  <a:ext uri="{0D108BD9-81ED-4DB2-BD59-A6C34878D82A}">
-                    <a16:rowId xmlns:a16="http://schemas.microsoft.com/office/drawing/2014/main" val="10001"/>
-                  </a:ext>
-                </a:extLst>
               </a:tr>
               <a:tr h="457200">
                 <a:tc>
@@ -4444,7 +4677,7 @@
                     <a:bodyPr/>
                     <a:lstStyle/>
                     <a:p>
-                      <a:pPr marL="0" indent="0">
+                      <a:pPr indent="0" marL="0">
                         <a:buNone/>
                       </a:pPr>
                       <a:r>
@@ -4512,7 +4745,7 @@
                     <a:bodyPr/>
                     <a:lstStyle/>
                     <a:p>
-                      <a:pPr marL="0" indent="0">
+                      <a:pPr indent="0" marL="0">
                         <a:buNone/>
                       </a:pPr>
                       <a:r>
@@ -4580,7 +4813,7 @@
                     <a:bodyPr/>
                     <a:lstStyle/>
                     <a:p>
-                      <a:pPr marL="0" indent="0">
+                      <a:pPr indent="0" marL="0">
                         <a:buNone/>
                       </a:pPr>
                       <a:r>
@@ -4648,7 +4881,7 @@
                     <a:bodyPr/>
                     <a:lstStyle/>
                     <a:p>
-                      <a:pPr marL="0" indent="0">
+                      <a:pPr indent="0" marL="0">
                         <a:buNone/>
                       </a:pPr>
                       <a:r>
@@ -4711,11 +4944,6 @@
                     </a:solidFill>
                   </a:tcPr>
                 </a:tc>
-                <a:extLst>
-                  <a:ext uri="{0D108BD9-81ED-4DB2-BD59-A6C34878D82A}">
-                    <a16:rowId xmlns:a16="http://schemas.microsoft.com/office/drawing/2014/main" val="10002"/>
-                  </a:ext>
-                </a:extLst>
               </a:tr>
               <a:tr h="457200">
                 <a:tc>
@@ -4723,7 +4951,7 @@
                     <a:bodyPr/>
                     <a:lstStyle/>
                     <a:p>
-                      <a:pPr marL="0" indent="0">
+                      <a:pPr indent="0" marL="0">
                         <a:buNone/>
                       </a:pPr>
                       <a:r>
@@ -4791,7 +5019,7 @@
                     <a:bodyPr/>
                     <a:lstStyle/>
                     <a:p>
-                      <a:pPr marL="0" indent="0">
+                      <a:pPr indent="0" marL="0">
                         <a:buNone/>
                       </a:pPr>
                       <a:r>
@@ -4859,7 +5087,7 @@
                     <a:bodyPr/>
                     <a:lstStyle/>
                     <a:p>
-                      <a:pPr marL="0" indent="0">
+                      <a:pPr indent="0" marL="0">
                         <a:buNone/>
                       </a:pPr>
                       <a:r>
@@ -4927,7 +5155,7 @@
                     <a:bodyPr/>
                     <a:lstStyle/>
                     <a:p>
-                      <a:pPr marL="0" indent="0">
+                      <a:pPr indent="0" marL="0">
                         <a:buNone/>
                       </a:pPr>
                       <a:r>
@@ -4990,11 +5218,6 @@
                     </a:solidFill>
                   </a:tcPr>
                 </a:tc>
-                <a:extLst>
-                  <a:ext uri="{0D108BD9-81ED-4DB2-BD59-A6C34878D82A}">
-                    <a16:rowId xmlns:a16="http://schemas.microsoft.com/office/drawing/2014/main" val="10003"/>
-                  </a:ext>
-                </a:extLst>
               </a:tr>
               <a:tr h="457200">
                 <a:tc>
@@ -5002,7 +5225,7 @@
                     <a:bodyPr/>
                     <a:lstStyle/>
                     <a:p>
-                      <a:pPr marL="0" indent="0">
+                      <a:pPr indent="0" marL="0">
                         <a:buNone/>
                       </a:pPr>
                       <a:r>
@@ -5070,7 +5293,7 @@
                     <a:bodyPr/>
                     <a:lstStyle/>
                     <a:p>
-                      <a:pPr marL="0" indent="0">
+                      <a:pPr indent="0" marL="0">
                         <a:buNone/>
                       </a:pPr>
                       <a:r>
@@ -5138,7 +5361,7 @@
                     <a:bodyPr/>
                     <a:lstStyle/>
                     <a:p>
-                      <a:pPr marL="0" indent="0">
+                      <a:pPr indent="0" marL="0">
                         <a:buNone/>
                       </a:pPr>
                       <a:r>
@@ -5206,7 +5429,7 @@
                     <a:bodyPr/>
                     <a:lstStyle/>
                     <a:p>
-                      <a:pPr marL="0" indent="0">
+                      <a:pPr indent="0" marL="0">
                         <a:buNone/>
                       </a:pPr>
                       <a:r>
@@ -5269,11 +5492,6 @@
                     </a:solidFill>
                   </a:tcPr>
                 </a:tc>
-                <a:extLst>
-                  <a:ext uri="{0D108BD9-81ED-4DB2-BD59-A6C34878D82A}">
-                    <a16:rowId xmlns:a16="http://schemas.microsoft.com/office/drawing/2014/main" val="10004"/>
-                  </a:ext>
-                </a:extLst>
               </a:tr>
               <a:tr h="457200">
                 <a:tc>
@@ -5281,7 +5499,7 @@
                     <a:bodyPr/>
                     <a:lstStyle/>
                     <a:p>
-                      <a:pPr marL="0" indent="0">
+                      <a:pPr indent="0" marL="0">
                         <a:buNone/>
                       </a:pPr>
                       <a:r>
@@ -5349,7 +5567,7 @@
                     <a:bodyPr/>
                     <a:lstStyle/>
                     <a:p>
-                      <a:pPr marL="0" indent="0">
+                      <a:pPr indent="0" marL="0">
                         <a:buNone/>
                       </a:pPr>
                       <a:r>
@@ -5417,7 +5635,7 @@
                     <a:bodyPr/>
                     <a:lstStyle/>
                     <a:p>
-                      <a:pPr marL="0" indent="0">
+                      <a:pPr indent="0" marL="0">
                         <a:buNone/>
                       </a:pPr>
                       <a:r>
@@ -5485,7 +5703,7 @@
                     <a:bodyPr/>
                     <a:lstStyle/>
                     <a:p>
-                      <a:pPr marL="0" indent="0">
+                      <a:pPr indent="0" marL="0">
                         <a:buNone/>
                       </a:pPr>
                       <a:r>
@@ -5548,11 +5766,6 @@
                     </a:solidFill>
                   </a:tcPr>
                 </a:tc>
-                <a:extLst>
-                  <a:ext uri="{0D108BD9-81ED-4DB2-BD59-A6C34878D82A}">
-                    <a16:rowId xmlns:a16="http://schemas.microsoft.com/office/drawing/2014/main" val="10005"/>
-                  </a:ext>
-                </a:extLst>
               </a:tr>
               <a:tr h="457200">
                 <a:tc>
@@ -5560,7 +5773,7 @@
                     <a:bodyPr/>
                     <a:lstStyle/>
                     <a:p>
-                      <a:pPr marL="0" indent="0">
+                      <a:pPr indent="0" marL="0">
                         <a:buNone/>
                       </a:pPr>
                       <a:r>
@@ -5628,7 +5841,7 @@
                     <a:bodyPr/>
                     <a:lstStyle/>
                     <a:p>
-                      <a:pPr marL="0" indent="0">
+                      <a:pPr indent="0" marL="0">
                         <a:buNone/>
                       </a:pPr>
                       <a:r>
@@ -5696,7 +5909,7 @@
                     <a:bodyPr/>
                     <a:lstStyle/>
                     <a:p>
-                      <a:pPr marL="0" indent="0">
+                      <a:pPr indent="0" marL="0">
                         <a:buNone/>
                       </a:pPr>
                       <a:r>
@@ -5764,7 +5977,7 @@
                     <a:bodyPr/>
                     <a:lstStyle/>
                     <a:p>
-                      <a:pPr marL="0" indent="0">
+                      <a:pPr indent="0" marL="0">
                         <a:buNone/>
                       </a:pPr>
                       <a:r>
@@ -5827,11 +6040,6 @@
                     </a:solidFill>
                   </a:tcPr>
                 </a:tc>
-                <a:extLst>
-                  <a:ext uri="{0D108BD9-81ED-4DB2-BD59-A6C34878D82A}">
-                    <a16:rowId xmlns:a16="http://schemas.microsoft.com/office/drawing/2014/main" val="10006"/>
-                  </a:ext>
-                </a:extLst>
               </a:tr>
               <a:tr h="457200">
                 <a:tc>
@@ -5839,7 +6047,7 @@
                     <a:bodyPr/>
                     <a:lstStyle/>
                     <a:p>
-                      <a:pPr marL="0" indent="0">
+                      <a:pPr indent="0" marL="0">
                         <a:buNone/>
                       </a:pPr>
                       <a:r>
@@ -5907,7 +6115,7 @@
                     <a:bodyPr/>
                     <a:lstStyle/>
                     <a:p>
-                      <a:pPr marL="0" indent="0">
+                      <a:pPr indent="0" marL="0">
                         <a:buNone/>
                       </a:pPr>
                       <a:r>
@@ -5975,7 +6183,7 @@
                     <a:bodyPr/>
                     <a:lstStyle/>
                     <a:p>
-                      <a:pPr marL="0" indent="0">
+                      <a:pPr indent="0" marL="0">
                         <a:buNone/>
                       </a:pPr>
                       <a:r>
@@ -6043,7 +6251,7 @@
                     <a:bodyPr/>
                     <a:lstStyle/>
                     <a:p>
-                      <a:pPr marL="0" indent="0">
+                      <a:pPr indent="0" marL="0">
                         <a:buNone/>
                       </a:pPr>
                       <a:r>
@@ -6106,11 +6314,6 @@
                     </a:solidFill>
                   </a:tcPr>
                 </a:tc>
-                <a:extLst>
-                  <a:ext uri="{0D108BD9-81ED-4DB2-BD59-A6C34878D82A}">
-                    <a16:rowId xmlns:a16="http://schemas.microsoft.com/office/drawing/2014/main" val="10007"/>
-                  </a:ext>
-                </a:extLst>
               </a:tr>
               <a:tr h="457200">
                 <a:tc>
@@ -6118,7 +6321,7 @@
                     <a:bodyPr/>
                     <a:lstStyle/>
                     <a:p>
-                      <a:pPr marL="0" indent="0">
+                      <a:pPr indent="0" marL="0">
                         <a:buNone/>
                       </a:pPr>
                       <a:r>
@@ -6186,7 +6389,7 @@
                     <a:bodyPr/>
                     <a:lstStyle/>
                     <a:p>
-                      <a:pPr marL="0" indent="0">
+                      <a:pPr indent="0" marL="0">
                         <a:buNone/>
                       </a:pPr>
                       <a:r>
@@ -6254,7 +6457,7 @@
                     <a:bodyPr/>
                     <a:lstStyle/>
                     <a:p>
-                      <a:pPr marL="0" indent="0">
+                      <a:pPr indent="0" marL="0">
                         <a:buNone/>
                       </a:pPr>
                       <a:r>
@@ -6322,7 +6525,7 @@
                     <a:bodyPr/>
                     <a:lstStyle/>
                     <a:p>
-                      <a:pPr marL="0" indent="0">
+                      <a:pPr indent="0" marL="0">
                         <a:buNone/>
                       </a:pPr>
                       <a:r>
@@ -6385,11 +6588,6 @@
                     </a:solidFill>
                   </a:tcPr>
                 </a:tc>
-                <a:extLst>
-                  <a:ext uri="{0D108BD9-81ED-4DB2-BD59-A6C34878D82A}">
-                    <a16:rowId xmlns:a16="http://schemas.microsoft.com/office/drawing/2014/main" val="10008"/>
-                  </a:ext>
-                </a:extLst>
               </a:tr>
               <a:tr h="457200">
                 <a:tc>
@@ -6397,7 +6595,7 @@
                     <a:bodyPr/>
                     <a:lstStyle/>
                     <a:p>
-                      <a:pPr marL="0" indent="0">
+                      <a:pPr indent="0" marL="0">
                         <a:buNone/>
                       </a:pPr>
                       <a:r>
@@ -6465,7 +6663,7 @@
                     <a:bodyPr/>
                     <a:lstStyle/>
                     <a:p>
-                      <a:pPr marL="0" indent="0">
+                      <a:pPr indent="0" marL="0">
                         <a:buNone/>
                       </a:pPr>
                       <a:r>
@@ -6533,7 +6731,7 @@
                     <a:bodyPr/>
                     <a:lstStyle/>
                     <a:p>
-                      <a:pPr marL="0" indent="0">
+                      <a:pPr indent="0" marL="0">
                         <a:buNone/>
                       </a:pPr>
                       <a:r>
@@ -6601,7 +6799,7 @@
                     <a:bodyPr/>
                     <a:lstStyle/>
                     <a:p>
-                      <a:pPr marL="0" indent="0">
+                      <a:pPr indent="0" marL="0">
                         <a:buNone/>
                       </a:pPr>
                       <a:r>
@@ -6664,11 +6862,6 @@
                     </a:solidFill>
                   </a:tcPr>
                 </a:tc>
-                <a:extLst>
-                  <a:ext uri="{0D108BD9-81ED-4DB2-BD59-A6C34878D82A}">
-                    <a16:rowId xmlns:a16="http://schemas.microsoft.com/office/drawing/2014/main" val="10009"/>
-                  </a:ext>
-                </a:extLst>
               </a:tr>
             </a:tbl>
           </a:graphicData>
@@ -6695,7 +6888,7 @@
           <a:bodyPr wrap="square" rtlCol="0" anchor="ctr"/>
           <a:lstStyle/>
           <a:p>
-            <a:pPr marL="0" indent="0">
+            <a:pPr indent="0" marL="0">
               <a:buNone/>
             </a:pPr>
             <a:r>
@@ -6729,7 +6922,6 @@
         <a:solidFill>
           <a:srgbClr val="FFFFFF"/>
         </a:solidFill>
-        <a:effectLst/>
       </p:bgPr>
     </p:bg>
     <p:spTree>
@@ -6767,11 +6959,11 @@
           <a:bodyPr wrap="square" rtlCol="0" anchor="ctr"/>
           <a:lstStyle/>
           <a:p>
-            <a:pPr marL="0" indent="0">
-              <a:buNone/>
-            </a:pPr>
-            <a:r>
-              <a:rPr lang="en-US" sz="1300" b="1" kern="0" spc="300" dirty="0">
+            <a:pPr indent="0" marL="0">
+              <a:buNone/>
+            </a:pPr>
+            <a:r>
+              <a:rPr lang="en-US" sz="1300" b="1" spc="300" kern="0" dirty="0">
                 <a:solidFill>
                   <a:srgbClr val="B02621"/>
                 </a:solidFill>
@@ -6806,7 +6998,7 @@
           <a:bodyPr wrap="square" rtlCol="0" anchor="ctr"/>
           <a:lstStyle/>
           <a:p>
-            <a:pPr marL="0" indent="0">
+            <a:pPr indent="0" marL="0">
               <a:buNone/>
             </a:pPr>
             <a:r>
@@ -6845,7 +7037,7 @@
           <a:bodyPr wrap="square" rtlCol="0" anchor="ctr"/>
           <a:lstStyle/>
           <a:p>
-            <a:pPr marL="0" indent="0">
+            <a:pPr indent="0" marL="0">
               <a:buNone/>
             </a:pPr>
             <a:r>
@@ -6884,7 +7076,7 @@
           <a:bodyPr wrap="square" rtlCol="0" anchor="ctr"/>
           <a:lstStyle/>
           <a:p>
-            <a:pPr marL="0" indent="0" algn="r">
+            <a:pPr algn="r" indent="0" marL="0">
               <a:buNone/>
             </a:pPr>
             <a:r>
@@ -6923,7 +7115,7 @@
           <a:bodyPr wrap="square" rtlCol="0" anchor="t"/>
           <a:lstStyle/>
           <a:p>
-            <a:pPr marL="0" indent="0">
+            <a:pPr indent="0" marL="0">
               <a:lnSpc>
                 <a:spcPct val="108000"/>
               </a:lnSpc>
@@ -6946,7 +7138,7 @@
             <a:endParaRPr lang="en-US" sz="1850" dirty="0"/>
           </a:p>
           <a:p>
-            <a:pPr marL="0" indent="0">
+            <a:pPr indent="0" marL="0">
               <a:lnSpc>
                 <a:spcPct val="108000"/>
               </a:lnSpc>
@@ -6969,7 +7161,7 @@
             <a:endParaRPr lang="en-US" sz="1850" dirty="0"/>
           </a:p>
           <a:p>
-            <a:pPr marL="0" indent="0">
+            <a:pPr indent="0" marL="0">
               <a:lnSpc>
                 <a:spcPct val="108000"/>
               </a:lnSpc>
@@ -6995,14 +7187,14 @@
       </p:sp>
       <p:pic>
         <p:nvPicPr>
-          <p:cNvPr id="7" name="Image 0" descr="figs/figT_truth.png"/>
+          <p:cNvPr id="7" name="Image 0" descr="figs/figT_truth.png">    </p:cNvPr>
           <p:cNvPicPr>
             <a:picLocks noChangeAspect="1"/>
           </p:cNvPicPr>
           <p:nvPr/>
         </p:nvPicPr>
         <p:blipFill>
-          <a:blip r:embed="rId3"/>
+          <a:blip r:embed="rId1"/>
           <a:stretch>
             <a:fillRect/>
           </a:stretch>
@@ -7033,7 +7225,6 @@
         <a:solidFill>
           <a:srgbClr val="FFFFFF"/>
         </a:solidFill>
-        <a:effectLst/>
       </p:bgPr>
     </p:bg>
     <p:spTree>
@@ -7071,11 +7262,11 @@
           <a:bodyPr wrap="square" rtlCol="0" anchor="ctr"/>
           <a:lstStyle/>
           <a:p>
-            <a:pPr marL="0" indent="0">
-              <a:buNone/>
-            </a:pPr>
-            <a:r>
-              <a:rPr lang="en-US" sz="1300" b="1" kern="0" spc="300" dirty="0">
+            <a:pPr indent="0" marL="0">
+              <a:buNone/>
+            </a:pPr>
+            <a:r>
+              <a:rPr lang="en-US" sz="1300" b="1" spc="300" kern="0" dirty="0">
                 <a:solidFill>
                   <a:srgbClr val="B02621"/>
                 </a:solidFill>
@@ -7110,7 +7301,7 @@
           <a:bodyPr wrap="square" rtlCol="0" anchor="ctr"/>
           <a:lstStyle/>
           <a:p>
-            <a:pPr marL="0" indent="0">
+            <a:pPr indent="0" marL="0">
               <a:buNone/>
             </a:pPr>
             <a:r>
@@ -7149,7 +7340,7 @@
           <a:bodyPr wrap="square" rtlCol="0" anchor="ctr"/>
           <a:lstStyle/>
           <a:p>
-            <a:pPr marL="0" indent="0">
+            <a:pPr indent="0" marL="0">
               <a:buNone/>
             </a:pPr>
             <a:r>
@@ -7188,7 +7379,7 @@
           <a:bodyPr wrap="square" rtlCol="0" anchor="ctr"/>
           <a:lstStyle/>
           <a:p>
-            <a:pPr marL="0" indent="0" algn="r">
+            <a:pPr algn="r" indent="0" marL="0">
               <a:buNone/>
             </a:pPr>
             <a:r>
@@ -7227,7 +7418,7 @@
           <a:bodyPr wrap="square" rtlCol="0" anchor="t"/>
           <a:lstStyle/>
           <a:p>
-            <a:pPr marL="0" indent="0">
+            <a:pPr indent="0" marL="0">
               <a:lnSpc>
                 <a:spcPct val="108000"/>
               </a:lnSpc>
@@ -7250,7 +7441,7 @@
             <a:endParaRPr lang="en-US" sz="1850" dirty="0"/>
           </a:p>
           <a:p>
-            <a:pPr marL="0" indent="0">
+            <a:pPr indent="0" marL="0">
               <a:lnSpc>
                 <a:spcPct val="108000"/>
               </a:lnSpc>
@@ -7273,7 +7464,7 @@
             <a:endParaRPr lang="en-US" sz="1850" dirty="0"/>
           </a:p>
           <a:p>
-            <a:pPr marL="0" indent="0">
+            <a:pPr indent="0" marL="0">
               <a:lnSpc>
                 <a:spcPct val="108000"/>
               </a:lnSpc>
@@ -7299,14 +7490,14 @@
       </p:sp>
       <p:pic>
         <p:nvPicPr>
-          <p:cNvPr id="7" name="Image 0" descr="figs/fig2_auprc.png"/>
+          <p:cNvPr id="7" name="Image 0" descr="figs/fig2_auprc.png">    </p:cNvPr>
           <p:cNvPicPr>
             <a:picLocks noChangeAspect="1"/>
           </p:cNvPicPr>
           <p:nvPr/>
         </p:nvPicPr>
         <p:blipFill>
-          <a:blip r:embed="rId3"/>
+          <a:blip r:embed="rId1"/>
           <a:stretch>
             <a:fillRect/>
           </a:stretch>
@@ -7337,7 +7528,6 @@
         <a:solidFill>
           <a:srgbClr val="FFFFFF"/>
         </a:solidFill>
-        <a:effectLst/>
       </p:bgPr>
     </p:bg>
     <p:spTree>
@@ -7375,11 +7565,11 @@
           <a:bodyPr wrap="square" rtlCol="0" anchor="ctr"/>
           <a:lstStyle/>
           <a:p>
-            <a:pPr marL="0" indent="0">
-              <a:buNone/>
-            </a:pPr>
-            <a:r>
-              <a:rPr lang="en-US" sz="1300" b="1" kern="0" spc="300" dirty="0">
+            <a:pPr indent="0" marL="0">
+              <a:buNone/>
+            </a:pPr>
+            <a:r>
+              <a:rPr lang="en-US" sz="1300" b="1" spc="300" kern="0" dirty="0">
                 <a:solidFill>
                   <a:srgbClr val="B02621"/>
                 </a:solidFill>
@@ -7414,7 +7604,7 @@
           <a:bodyPr wrap="square" rtlCol="0" anchor="ctr"/>
           <a:lstStyle/>
           <a:p>
-            <a:pPr marL="0" indent="0">
+            <a:pPr indent="0" marL="0">
               <a:buNone/>
             </a:pPr>
             <a:r>
@@ -7453,7 +7643,7 @@
           <a:bodyPr wrap="square" rtlCol="0" anchor="ctr"/>
           <a:lstStyle/>
           <a:p>
-            <a:pPr marL="0" indent="0">
+            <a:pPr indent="0" marL="0">
               <a:buNone/>
             </a:pPr>
             <a:r>
@@ -7492,7 +7682,7 @@
           <a:bodyPr wrap="square" rtlCol="0" anchor="ctr"/>
           <a:lstStyle/>
           <a:p>
-            <a:pPr marL="0" indent="0" algn="r">
+            <a:pPr algn="r" indent="0" marL="0">
               <a:buNone/>
             </a:pPr>
             <a:r>
@@ -7531,7 +7721,7 @@
           <a:bodyPr wrap="square" rtlCol="0" anchor="t"/>
           <a:lstStyle/>
           <a:p>
-            <a:pPr marL="0" indent="0">
+            <a:pPr indent="0" marL="0">
               <a:lnSpc>
                 <a:spcPct val="108000"/>
               </a:lnSpc>
@@ -7554,7 +7744,7 @@
             <a:endParaRPr lang="en-US" sz="1850" dirty="0"/>
           </a:p>
           <a:p>
-            <a:pPr marL="0" indent="0">
+            <a:pPr indent="0" marL="0">
               <a:lnSpc>
                 <a:spcPct val="108000"/>
               </a:lnSpc>
@@ -7577,7 +7767,7 @@
             <a:endParaRPr lang="en-US" sz="1850" dirty="0"/>
           </a:p>
           <a:p>
-            <a:pPr marL="0" indent="0">
+            <a:pPr indent="0" marL="0">
               <a:lnSpc>
                 <a:spcPct val="108000"/>
               </a:lnSpc>
@@ -7603,14 +7793,14 @@
       </p:sp>
       <p:pic>
         <p:nvPicPr>
-          <p:cNvPr id="7" name="Image 0" descr="figs/figOP_oppoint.png"/>
+          <p:cNvPr id="7" name="Image 0" descr="figs/figOP_oppoint.png">    </p:cNvPr>
           <p:cNvPicPr>
             <a:picLocks noChangeAspect="1"/>
           </p:cNvPicPr>
           <p:nvPr/>
         </p:nvPicPr>
         <p:blipFill>
-          <a:blip r:embed="rId3"/>
+          <a:blip r:embed="rId1"/>
           <a:stretch>
             <a:fillRect/>
           </a:stretch>
@@ -7641,7 +7831,6 @@
         <a:solidFill>
           <a:srgbClr val="FFFFFF"/>
         </a:solidFill>
-        <a:effectLst/>
       </p:bgPr>
     </p:bg>
     <p:spTree>
@@ -7679,11 +7868,11 @@
           <a:bodyPr wrap="square" rtlCol="0" anchor="ctr"/>
           <a:lstStyle/>
           <a:p>
-            <a:pPr marL="0" indent="0">
-              <a:buNone/>
-            </a:pPr>
-            <a:r>
-              <a:rPr lang="en-US" sz="1300" b="1" kern="0" spc="300" dirty="0">
+            <a:pPr indent="0" marL="0">
+              <a:buNone/>
+            </a:pPr>
+            <a:r>
+              <a:rPr lang="en-US" sz="1300" b="1" spc="300" kern="0" dirty="0">
                 <a:solidFill>
                   <a:srgbClr val="B02621"/>
                 </a:solidFill>
@@ -7718,7 +7907,7 @@
           <a:bodyPr wrap="square" rtlCol="0" anchor="ctr"/>
           <a:lstStyle/>
           <a:p>
-            <a:pPr marL="0" indent="0">
+            <a:pPr indent="0" marL="0">
               <a:buNone/>
             </a:pPr>
             <a:r>
@@ -7757,7 +7946,7 @@
           <a:bodyPr wrap="square" rtlCol="0" anchor="ctr"/>
           <a:lstStyle/>
           <a:p>
-            <a:pPr marL="0" indent="0">
+            <a:pPr indent="0" marL="0">
               <a:buNone/>
             </a:pPr>
             <a:r>
@@ -7796,7 +7985,7 @@
           <a:bodyPr wrap="square" rtlCol="0" anchor="ctr"/>
           <a:lstStyle/>
           <a:p>
-            <a:pPr marL="0" indent="0" algn="r">
+            <a:pPr algn="r" indent="0" marL="0">
               <a:buNone/>
             </a:pPr>
             <a:r>
@@ -7835,7 +8024,7 @@
           <a:bodyPr wrap="square" rtlCol="0" anchor="t"/>
           <a:lstStyle/>
           <a:p>
-            <a:pPr marL="0" indent="0">
+            <a:pPr indent="0" marL="0">
               <a:lnSpc>
                 <a:spcPct val="108000"/>
               </a:lnSpc>
@@ -7858,7 +8047,7 @@
             <a:endParaRPr lang="en-US" sz="1850" dirty="0"/>
           </a:p>
           <a:p>
-            <a:pPr marL="0" indent="0">
+            <a:pPr indent="0" marL="0">
               <a:lnSpc>
                 <a:spcPct val="108000"/>
               </a:lnSpc>
@@ -7881,7 +8070,7 @@
             <a:endParaRPr lang="en-US" sz="1850" dirty="0"/>
           </a:p>
           <a:p>
-            <a:pPr marL="0" indent="0">
+            <a:pPr indent="0" marL="0">
               <a:lnSpc>
                 <a:spcPct val="108000"/>
               </a:lnSpc>
@@ -7907,14 +8096,14 @@
       </p:sp>
       <p:pic>
         <p:nvPicPr>
-          <p:cNvPr id="7" name="Image 0" descr="figs/figBUR_burden.png"/>
+          <p:cNvPr id="7" name="Image 0" descr="figs/figBUR_burden.png">    </p:cNvPr>
           <p:cNvPicPr>
             <a:picLocks noChangeAspect="1"/>
           </p:cNvPicPr>
           <p:nvPr/>
         </p:nvPicPr>
         <p:blipFill>
-          <a:blip r:embed="rId3"/>
+          <a:blip r:embed="rId1"/>
           <a:stretch>
             <a:fillRect/>
           </a:stretch>
@@ -7945,7 +8134,6 @@
         <a:solidFill>
           <a:srgbClr val="FFFFFF"/>
         </a:solidFill>
-        <a:effectLst/>
       </p:bgPr>
     </p:bg>
     <p:spTree>
@@ -7983,11 +8171,11 @@
           <a:bodyPr wrap="square" rtlCol="0" anchor="ctr"/>
           <a:lstStyle/>
           <a:p>
-            <a:pPr marL="0" indent="0">
-              <a:buNone/>
-            </a:pPr>
-            <a:r>
-              <a:rPr lang="en-US" sz="1300" b="1" kern="0" spc="300" dirty="0">
+            <a:pPr indent="0" marL="0">
+              <a:buNone/>
+            </a:pPr>
+            <a:r>
+              <a:rPr lang="en-US" sz="1300" b="1" spc="300" kern="0" dirty="0">
                 <a:solidFill>
                   <a:srgbClr val="B02621"/>
                 </a:solidFill>
@@ -8022,7 +8210,7 @@
           <a:bodyPr wrap="square" rtlCol="0" anchor="ctr"/>
           <a:lstStyle/>
           <a:p>
-            <a:pPr marL="0" indent="0">
+            <a:pPr indent="0" marL="0">
               <a:buNone/>
             </a:pPr>
             <a:r>
@@ -8061,7 +8249,7 @@
           <a:bodyPr wrap="square" rtlCol="0" anchor="ctr"/>
           <a:lstStyle/>
           <a:p>
-            <a:pPr marL="0" indent="0">
+            <a:pPr indent="0" marL="0">
               <a:buNone/>
             </a:pPr>
             <a:r>
@@ -8100,7 +8288,7 @@
           <a:bodyPr wrap="square" rtlCol="0" anchor="ctr"/>
           <a:lstStyle/>
           <a:p>
-            <a:pPr marL="0" indent="0" algn="r">
+            <a:pPr algn="r" indent="0" marL="0">
               <a:buNone/>
             </a:pPr>
             <a:r>
@@ -8139,7 +8327,7 @@
           <a:bodyPr wrap="square" rtlCol="0" anchor="t"/>
           <a:lstStyle/>
           <a:p>
-            <a:pPr marL="0" indent="0">
+            <a:pPr indent="0" marL="0">
               <a:lnSpc>
                 <a:spcPct val="108000"/>
               </a:lnSpc>
@@ -8162,7 +8350,7 @@
             <a:endParaRPr lang="en-US" sz="1850" dirty="0"/>
           </a:p>
           <a:p>
-            <a:pPr marL="0" indent="0">
+            <a:pPr indent="0" marL="0">
               <a:lnSpc>
                 <a:spcPct val="108000"/>
               </a:lnSpc>
@@ -8185,7 +8373,7 @@
             <a:endParaRPr lang="en-US" sz="1850" dirty="0"/>
           </a:p>
           <a:p>
-            <a:pPr marL="0" indent="0">
+            <a:pPr indent="0" marL="0">
               <a:lnSpc>
                 <a:spcPct val="108000"/>
               </a:lnSpc>
@@ -8211,14 +8399,14 @@
       </p:sp>
       <p:pic>
         <p:nvPicPr>
-          <p:cNvPr id="7" name="Image 0" descr="figs/fig3_calibration.png"/>
+          <p:cNvPr id="7" name="Image 0" descr="figs/fig3_calibration.png">    </p:cNvPr>
           <p:cNvPicPr>
             <a:picLocks noChangeAspect="1"/>
           </p:cNvPicPr>
           <p:nvPr/>
         </p:nvPicPr>
         <p:blipFill>
-          <a:blip r:embed="rId3"/>
+          <a:blip r:embed="rId1"/>
           <a:stretch>
             <a:fillRect/>
           </a:stretch>
@@ -8249,7 +8437,6 @@
         <a:solidFill>
           <a:srgbClr val="FFFFFF"/>
         </a:solidFill>
-        <a:effectLst/>
       </p:bgPr>
     </p:bg>
     <p:spTree>
@@ -8287,11 +8474,11 @@
           <a:bodyPr wrap="square" rtlCol="0" anchor="ctr"/>
           <a:lstStyle/>
           <a:p>
-            <a:pPr marL="0" indent="0">
-              <a:buNone/>
-            </a:pPr>
-            <a:r>
-              <a:rPr lang="en-US" sz="1300" b="1" kern="0" spc="300" dirty="0">
+            <a:pPr indent="0" marL="0">
+              <a:buNone/>
+            </a:pPr>
+            <a:r>
+              <a:rPr lang="en-US" sz="1300" b="1" spc="300" kern="0" dirty="0">
                 <a:solidFill>
                   <a:srgbClr val="B02621"/>
                 </a:solidFill>
@@ -8326,7 +8513,7 @@
           <a:bodyPr wrap="square" rtlCol="0" anchor="ctr"/>
           <a:lstStyle/>
           <a:p>
-            <a:pPr marL="0" indent="0">
+            <a:pPr indent="0" marL="0">
               <a:buNone/>
             </a:pPr>
             <a:r>
@@ -8365,7 +8552,7 @@
           <a:bodyPr wrap="square" rtlCol="0" anchor="ctr"/>
           <a:lstStyle/>
           <a:p>
-            <a:pPr marL="0" indent="0">
+            <a:pPr indent="0" marL="0">
               <a:buNone/>
             </a:pPr>
             <a:r>
@@ -8404,7 +8591,7 @@
           <a:bodyPr wrap="square" rtlCol="0" anchor="ctr"/>
           <a:lstStyle/>
           <a:p>
-            <a:pPr marL="0" indent="0" algn="r">
+            <a:pPr algn="r" indent="0" marL="0">
               <a:buNone/>
             </a:pPr>
             <a:r>
@@ -8443,7 +8630,7 @@
           <a:bodyPr wrap="square" rtlCol="0" anchor="t"/>
           <a:lstStyle/>
           <a:p>
-            <a:pPr marL="0" indent="0">
+            <a:pPr indent="0" marL="0">
               <a:lnSpc>
                 <a:spcPct val="108000"/>
               </a:lnSpc>
@@ -8466,7 +8653,7 @@
             <a:endParaRPr lang="en-US" sz="1850" dirty="0"/>
           </a:p>
           <a:p>
-            <a:pPr marL="0" indent="0">
+            <a:pPr indent="0" marL="0">
               <a:lnSpc>
                 <a:spcPct val="108000"/>
               </a:lnSpc>
@@ -8489,7 +8676,7 @@
             <a:endParaRPr lang="en-US" sz="1850" dirty="0"/>
           </a:p>
           <a:p>
-            <a:pPr marL="0" indent="0">
+            <a:pPr indent="0" marL="0">
               <a:lnSpc>
                 <a:spcPct val="108000"/>
               </a:lnSpc>
@@ -8515,14 +8702,14 @@
       </p:sp>
       <p:pic>
         <p:nvPicPr>
-          <p:cNvPr id="7" name="Image 0" descr="figs/figCAL_calib.png"/>
+          <p:cNvPr id="7" name="Image 0" descr="figs/figCAL_calib.png">    </p:cNvPr>
           <p:cNvPicPr>
             <a:picLocks noChangeAspect="1"/>
           </p:cNvPicPr>
           <p:nvPr/>
         </p:nvPicPr>
         <p:blipFill>
-          <a:blip r:embed="rId3"/>
+          <a:blip r:embed="rId1"/>
           <a:stretch>
             <a:fillRect/>
           </a:stretch>
@@ -8553,7 +8740,6 @@
         <a:solidFill>
           <a:srgbClr val="FFFFFF"/>
         </a:solidFill>
-        <a:effectLst/>
       </p:bgPr>
     </p:bg>
     <p:spTree>
@@ -8591,11 +8777,11 @@
           <a:bodyPr wrap="square" rtlCol="0" anchor="ctr"/>
           <a:lstStyle/>
           <a:p>
-            <a:pPr marL="0" indent="0">
-              <a:buNone/>
-            </a:pPr>
-            <a:r>
-              <a:rPr lang="en-US" sz="1300" b="1" kern="0" spc="300" dirty="0">
+            <a:pPr indent="0" marL="0">
+              <a:buNone/>
+            </a:pPr>
+            <a:r>
+              <a:rPr lang="en-US" sz="1300" b="1" spc="300" kern="0" dirty="0">
                 <a:solidFill>
                   <a:srgbClr val="B02621"/>
                 </a:solidFill>
@@ -8630,7 +8816,7 @@
           <a:bodyPr wrap="square" rtlCol="0" anchor="ctr"/>
           <a:lstStyle/>
           <a:p>
-            <a:pPr marL="0" indent="0">
+            <a:pPr indent="0" marL="0">
               <a:buNone/>
             </a:pPr>
             <a:r>
@@ -8669,7 +8855,7 @@
           <a:bodyPr wrap="square" rtlCol="0" anchor="ctr"/>
           <a:lstStyle/>
           <a:p>
-            <a:pPr marL="0" indent="0">
+            <a:pPr indent="0" marL="0">
               <a:buNone/>
             </a:pPr>
             <a:r>
@@ -8708,7 +8894,7 @@
           <a:bodyPr wrap="square" rtlCol="0" anchor="ctr"/>
           <a:lstStyle/>
           <a:p>
-            <a:pPr marL="0" indent="0" algn="r">
+            <a:pPr algn="r" indent="0" marL="0">
               <a:buNone/>
             </a:pPr>
             <a:r>
@@ -8747,7 +8933,7 @@
           <a:bodyPr wrap="square" rtlCol="0" anchor="t"/>
           <a:lstStyle/>
           <a:p>
-            <a:pPr marL="0" indent="0">
+            <a:pPr indent="0" marL="0">
               <a:lnSpc>
                 <a:spcPct val="108000"/>
               </a:lnSpc>
@@ -8770,7 +8956,7 @@
             <a:endParaRPr lang="en-US" sz="1850" dirty="0"/>
           </a:p>
           <a:p>
-            <a:pPr marL="0" indent="0">
+            <a:pPr indent="0" marL="0">
               <a:lnSpc>
                 <a:spcPct val="108000"/>
               </a:lnSpc>
@@ -8793,7 +8979,7 @@
             <a:endParaRPr lang="en-US" sz="1850" dirty="0"/>
           </a:p>
           <a:p>
-            <a:pPr marL="0" indent="0">
+            <a:pPr indent="0" marL="0">
               <a:lnSpc>
                 <a:spcPct val="108000"/>
               </a:lnSpc>
@@ -8819,14 +9005,14 @@
       </p:sp>
       <p:pic>
         <p:nvPicPr>
-          <p:cNvPr id="7" name="Image 0" descr="figs/fig4_drift.png"/>
+          <p:cNvPr id="7" name="Image 0" descr="figs/fig4_drift.png">    </p:cNvPr>
           <p:cNvPicPr>
             <a:picLocks noChangeAspect="1"/>
           </p:cNvPicPr>
           <p:nvPr/>
         </p:nvPicPr>
         <p:blipFill>
-          <a:blip r:embed="rId3"/>
+          <a:blip r:embed="rId1"/>
           <a:stretch>
             <a:fillRect/>
           </a:stretch>
@@ -8857,7 +9043,6 @@
         <a:solidFill>
           <a:srgbClr val="FFFFFF"/>
         </a:solidFill>
-        <a:effectLst/>
       </p:bgPr>
     </p:bg>
     <p:spTree>
@@ -8895,11 +9080,11 @@
           <a:bodyPr wrap="square" rtlCol="0" anchor="ctr"/>
           <a:lstStyle/>
           <a:p>
-            <a:pPr marL="0" indent="0">
-              <a:buNone/>
-            </a:pPr>
-            <a:r>
-              <a:rPr lang="en-US" sz="1300" b="1" kern="0" spc="300" dirty="0">
+            <a:pPr indent="0" marL="0">
+              <a:buNone/>
+            </a:pPr>
+            <a:r>
+              <a:rPr lang="en-US" sz="1300" b="1" spc="300" kern="0" dirty="0">
                 <a:solidFill>
                   <a:srgbClr val="B02621"/>
                 </a:solidFill>
@@ -8934,7 +9119,7 @@
           <a:bodyPr wrap="square" rtlCol="0" anchor="ctr"/>
           <a:lstStyle/>
           <a:p>
-            <a:pPr marL="0" indent="0">
+            <a:pPr indent="0" marL="0">
               <a:buNone/>
             </a:pPr>
             <a:r>
@@ -8973,7 +9158,7 @@
           <a:bodyPr wrap="square" rtlCol="0" anchor="ctr"/>
           <a:lstStyle/>
           <a:p>
-            <a:pPr marL="0" indent="0">
+            <a:pPr indent="0" marL="0">
               <a:buNone/>
             </a:pPr>
             <a:r>
@@ -9012,7 +9197,7 @@
           <a:bodyPr wrap="square" rtlCol="0" anchor="ctr"/>
           <a:lstStyle/>
           <a:p>
-            <a:pPr marL="0" indent="0" algn="r">
+            <a:pPr algn="r" indent="0" marL="0">
               <a:buNone/>
             </a:pPr>
             <a:r>
@@ -9051,7 +9236,7 @@
           <a:bodyPr wrap="square" rtlCol="0" anchor="t"/>
           <a:lstStyle/>
           <a:p>
-            <a:pPr marL="0" indent="0">
+            <a:pPr indent="0" marL="0">
               <a:lnSpc>
                 <a:spcPct val="108000"/>
               </a:lnSpc>
@@ -9074,7 +9259,7 @@
             <a:endParaRPr lang="en-US" sz="1850" dirty="0"/>
           </a:p>
           <a:p>
-            <a:pPr marL="0" indent="0">
+            <a:pPr indent="0" marL="0">
               <a:lnSpc>
                 <a:spcPct val="108000"/>
               </a:lnSpc>
@@ -9097,7 +9282,7 @@
             <a:endParaRPr lang="en-US" sz="1850" dirty="0"/>
           </a:p>
           <a:p>
-            <a:pPr marL="0" indent="0">
+            <a:pPr indent="0" marL="0">
               <a:lnSpc>
                 <a:spcPct val="108000"/>
               </a:lnSpc>
@@ -9123,14 +9308,14 @@
       </p:sp>
       <p:pic>
         <p:nvPicPr>
-          <p:cNvPr id="7" name="Image 0" descr="figs/figDEC_decision.png"/>
+          <p:cNvPr id="7" name="Image 0" descr="figs/figDEC_decision.png">    </p:cNvPr>
           <p:cNvPicPr>
             <a:picLocks noChangeAspect="1"/>
           </p:cNvPicPr>
           <p:nvPr/>
         </p:nvPicPr>
         <p:blipFill>
-          <a:blip r:embed="rId3"/>
+          <a:blip r:embed="rId1"/>
           <a:stretch>
             <a:fillRect/>
           </a:stretch>
@@ -9446,319 +9631,4 @@
     </a:ext>
   </a:extLst>
 </a:theme>
-</file>
-
-<file path=ppt/theme/theme2.xml><?xml version="1.0" encoding="utf-8"?>
-<a:theme xmlns:a="http://schemas.openxmlformats.org/drawingml/2006/main" name="Office Theme">
-  <a:themeElements>
-    <a:clrScheme name="Office">
-      <a:dk1>
-        <a:sysClr val="windowText" lastClr="000000"/>
-      </a:dk1>
-      <a:lt1>
-        <a:sysClr val="window" lastClr="FFFFFF"/>
-      </a:lt1>
-      <a:dk2>
-        <a:srgbClr val="0E2841"/>
-      </a:dk2>
-      <a:lt2>
-        <a:srgbClr val="E8E8E8"/>
-      </a:lt2>
-      <a:accent1>
-        <a:srgbClr val="156082"/>
-      </a:accent1>
-      <a:accent2>
-        <a:srgbClr val="E97132"/>
-      </a:accent2>
-      <a:accent3>
-        <a:srgbClr val="196B24"/>
-      </a:accent3>
-      <a:accent4>
-        <a:srgbClr val="0F9ED5"/>
-      </a:accent4>
-      <a:accent5>
-        <a:srgbClr val="A02B93"/>
-      </a:accent5>
-      <a:accent6>
-        <a:srgbClr val="4EA72E"/>
-      </a:accent6>
-      <a:hlink>
-        <a:srgbClr val="467886"/>
-      </a:hlink>
-      <a:folHlink>
-        <a:srgbClr val="96607D"/>
-      </a:folHlink>
-    </a:clrScheme>
-    <a:fontScheme name="Office">
-      <a:majorFont>
-        <a:latin typeface="Aptos Display" panose="02110004020202020204"/>
-        <a:ea typeface=""/>
-        <a:cs typeface=""/>
-        <a:font script="Jpan" typeface="游ゴシック Light"/>
-        <a:font script="Hang" typeface="맑은 고딕"/>
-        <a:font script="Hans" typeface="等线 Light"/>
-        <a:font script="Hant" typeface="新細明體"/>
-        <a:font script="Arab" typeface="Times New Roman"/>
-        <a:font script="Hebr" typeface="Times New Roman"/>
-        <a:font script="Thai" typeface="Angsana New"/>
-        <a:font script="Ethi" typeface="Nyala"/>
-        <a:font script="Beng" typeface="Vrinda"/>
-        <a:font script="Gujr" typeface="Shruti"/>
-        <a:font script="Khmr" typeface="MoolBoran"/>
-        <a:font script="Knda" typeface="Tunga"/>
-        <a:font script="Guru" typeface="Raavi"/>
-        <a:font script="Cans" typeface="Euphemia"/>
-        <a:font script="Cher" typeface="Plantagenet Cherokee"/>
-        <a:font script="Yiii" typeface="Microsoft Yi Baiti"/>
-        <a:font script="Tibt" typeface="Microsoft Himalaya"/>
-        <a:font script="Thaa" typeface="MV Boli"/>
-        <a:font script="Deva" typeface="Mangal"/>
-        <a:font script="Telu" typeface="Gautami"/>
-        <a:font script="Taml" typeface="Latha"/>
-        <a:font script="Syrc" typeface="Estrangelo Edessa"/>
-        <a:font script="Orya" typeface="Kalinga"/>
-        <a:font script="Mlym" typeface="Kartika"/>
-        <a:font script="Laoo" typeface="DokChampa"/>
-        <a:font script="Sinh" typeface="Iskoola Pota"/>
-        <a:font script="Mong" typeface="Mongolian Baiti"/>
-        <a:font script="Viet" typeface="Times New Roman"/>
-        <a:font script="Uigh" typeface="Microsoft Uighur"/>
-        <a:font script="Geor" typeface="Sylfaen"/>
-        <a:font script="Armn" typeface="Arial"/>
-        <a:font script="Bugi" typeface="Leelawadee UI"/>
-        <a:font script="Bopo" typeface="Microsoft JhengHei"/>
-        <a:font script="Java" typeface="Javanese Text"/>
-        <a:font script="Lisu" typeface="Segoe UI"/>
-        <a:font script="Mymr" typeface="Myanmar Text"/>
-        <a:font script="Nkoo" typeface="Ebrima"/>
-        <a:font script="Olck" typeface="Nirmala UI"/>
-        <a:font script="Osma" typeface="Ebrima"/>
-        <a:font script="Phag" typeface="Phagspa"/>
-        <a:font script="Syrn" typeface="Estrangelo Edessa"/>
-        <a:font script="Syrj" typeface="Estrangelo Edessa"/>
-        <a:font script="Syre" typeface="Estrangelo Edessa"/>
-        <a:font script="Sora" typeface="Nirmala UI"/>
-        <a:font script="Tale" typeface="Microsoft Tai Le"/>
-        <a:font script="Talu" typeface="Microsoft New Tai Lue"/>
-        <a:font script="Tfng" typeface="Ebrima"/>
-      </a:majorFont>
-      <a:minorFont>
-        <a:latin typeface="Aptos" panose="02110004020202020204"/>
-        <a:ea typeface=""/>
-        <a:cs typeface=""/>
-        <a:font script="Jpan" typeface="游ゴシック"/>
-        <a:font script="Hang" typeface="맑은 고딕"/>
-        <a:font script="Hans" typeface="等线"/>
-        <a:font script="Hant" typeface="新細明體"/>
-        <a:font script="Arab" typeface="Arial"/>
-        <a:font script="Hebr" typeface="Arial"/>
-        <a:font script="Thai" typeface="Cordia New"/>
-        <a:font script="Ethi" typeface="Nyala"/>
-        <a:font script="Beng" typeface="Vrinda"/>
-        <a:font script="Gujr" typeface="Shruti"/>
-        <a:font script="Khmr" typeface="DaunPenh"/>
-        <a:font script="Knda" typeface="Tunga"/>
-        <a:font script="Guru" typeface="Raavi"/>
-        <a:font script="Cans" typeface="Euphemia"/>
-        <a:font script="Cher" typeface="Plantagenet Cherokee"/>
-        <a:font script="Yiii" typeface="Microsoft Yi Baiti"/>
-        <a:font script="Tibt" typeface="Microsoft Himalaya"/>
-        <a:font script="Thaa" typeface="MV Boli"/>
-        <a:font script="Deva" typeface="Mangal"/>
-        <a:font script="Telu" typeface="Gautami"/>
-        <a:font script="Taml" typeface="Latha"/>
-        <a:font script="Syrc" typeface="Estrangelo Edessa"/>
-        <a:font script="Orya" typeface="Kalinga"/>
-        <a:font script="Mlym" typeface="Kartika"/>
-        <a:font script="Laoo" typeface="DokChampa"/>
-        <a:font script="Sinh" typeface="Iskoola Pota"/>
-        <a:font script="Mong" typeface="Mongolian Baiti"/>
-        <a:font script="Viet" typeface="Arial"/>
-        <a:font script="Uigh" typeface="Microsoft Uighur"/>
-        <a:font script="Geor" typeface="Sylfaen"/>
-        <a:font script="Armn" typeface="Arial"/>
-        <a:font script="Bugi" typeface="Leelawadee UI"/>
-        <a:font script="Bopo" typeface="Microsoft JhengHei"/>
-        <a:font script="Java" typeface="Javanese Text"/>
-        <a:font script="Lisu" typeface="Segoe UI"/>
-        <a:font script="Mymr" typeface="Myanmar Text"/>
-        <a:font script="Nkoo" typeface="Ebrima"/>
-        <a:font script="Olck" typeface="Nirmala UI"/>
-        <a:font script="Osma" typeface="Ebrima"/>
-        <a:font script="Phag" typeface="Phagspa"/>
-        <a:font script="Syrn" typeface="Estrangelo Edessa"/>
-        <a:font script="Syrj" typeface="Estrangelo Edessa"/>
-        <a:font script="Syre" typeface="Estrangelo Edessa"/>
-        <a:font script="Sora" typeface="Nirmala UI"/>
-        <a:font script="Tale" typeface="Microsoft Tai Le"/>
-        <a:font script="Talu" typeface="Microsoft New Tai Lue"/>
-        <a:font script="Tfng" typeface="Ebrima"/>
-      </a:minorFont>
-    </a:fontScheme>
-    <a:fmtScheme name="Office">
-      <a:fillStyleLst>
-        <a:solidFill>
-          <a:schemeClr val="phClr"/>
-        </a:solidFill>
-        <a:gradFill rotWithShape="1">
-          <a:gsLst>
-            <a:gs pos="0">
-              <a:schemeClr val="phClr">
-                <a:lumMod val="110000"/>
-                <a:satMod val="105000"/>
-                <a:tint val="67000"/>
-              </a:schemeClr>
-            </a:gs>
-            <a:gs pos="50000">
-              <a:schemeClr val="phClr">
-                <a:lumMod val="105000"/>
-                <a:satMod val="103000"/>
-                <a:tint val="73000"/>
-              </a:schemeClr>
-            </a:gs>
-            <a:gs pos="100000">
-              <a:schemeClr val="phClr">
-                <a:lumMod val="105000"/>
-                <a:satMod val="109000"/>
-                <a:tint val="81000"/>
-              </a:schemeClr>
-            </a:gs>
-          </a:gsLst>
-          <a:lin ang="5400000" scaled="0"/>
-        </a:gradFill>
-        <a:gradFill rotWithShape="1">
-          <a:gsLst>
-            <a:gs pos="0">
-              <a:schemeClr val="phClr">
-                <a:satMod val="103000"/>
-                <a:lumMod val="102000"/>
-                <a:tint val="94000"/>
-              </a:schemeClr>
-            </a:gs>
-            <a:gs pos="50000">
-              <a:schemeClr val="phClr">
-                <a:satMod val="110000"/>
-                <a:lumMod val="100000"/>
-                <a:shade val="100000"/>
-              </a:schemeClr>
-            </a:gs>
-            <a:gs pos="100000">
-              <a:schemeClr val="phClr">
-                <a:lumMod val="99000"/>
-                <a:satMod val="120000"/>
-                <a:shade val="78000"/>
-              </a:schemeClr>
-            </a:gs>
-          </a:gsLst>
-          <a:lin ang="5400000" scaled="0"/>
-        </a:gradFill>
-      </a:fillStyleLst>
-      <a:lnStyleLst>
-        <a:ln w="12700" cap="flat" cmpd="sng" algn="ctr">
-          <a:solidFill>
-            <a:schemeClr val="phClr"/>
-          </a:solidFill>
-          <a:prstDash val="solid"/>
-          <a:miter lim="800000"/>
-        </a:ln>
-        <a:ln w="19050" cap="flat" cmpd="sng" algn="ctr">
-          <a:solidFill>
-            <a:schemeClr val="phClr"/>
-          </a:solidFill>
-          <a:prstDash val="solid"/>
-          <a:miter lim="800000"/>
-        </a:ln>
-        <a:ln w="25400" cap="flat" cmpd="sng" algn="ctr">
-          <a:solidFill>
-            <a:schemeClr val="phClr"/>
-          </a:solidFill>
-          <a:prstDash val="solid"/>
-          <a:miter lim="800000"/>
-        </a:ln>
-      </a:lnStyleLst>
-      <a:effectStyleLst>
-        <a:effectStyle>
-          <a:effectLst/>
-        </a:effectStyle>
-        <a:effectStyle>
-          <a:effectLst/>
-        </a:effectStyle>
-        <a:effectStyle>
-          <a:effectLst>
-            <a:outerShdw blurRad="57150" dist="19050" dir="5400000" algn="ctr" rotWithShape="0">
-              <a:srgbClr val="000000">
-                <a:alpha val="63000"/>
-              </a:srgbClr>
-            </a:outerShdw>
-          </a:effectLst>
-        </a:effectStyle>
-      </a:effectStyleLst>
-      <a:bgFillStyleLst>
-        <a:solidFill>
-          <a:schemeClr val="phClr"/>
-        </a:solidFill>
-        <a:solidFill>
-          <a:schemeClr val="phClr">
-            <a:tint val="95000"/>
-            <a:satMod val="170000"/>
-          </a:schemeClr>
-        </a:solidFill>
-        <a:gradFill rotWithShape="1">
-          <a:gsLst>
-            <a:gs pos="0">
-              <a:schemeClr val="phClr">
-                <a:tint val="93000"/>
-                <a:satMod val="150000"/>
-                <a:shade val="98000"/>
-                <a:lumMod val="102000"/>
-              </a:schemeClr>
-            </a:gs>
-            <a:gs pos="50000">
-              <a:schemeClr val="phClr">
-                <a:tint val="98000"/>
-                <a:satMod val="130000"/>
-                <a:shade val="90000"/>
-                <a:lumMod val="103000"/>
-              </a:schemeClr>
-            </a:gs>
-            <a:gs pos="100000">
-              <a:schemeClr val="phClr">
-                <a:shade val="63000"/>
-                <a:satMod val="120000"/>
-              </a:schemeClr>
-            </a:gs>
-          </a:gsLst>
-          <a:lin ang="5400000" scaled="0"/>
-        </a:gradFill>
-      </a:bgFillStyleLst>
-    </a:fmtScheme>
-  </a:themeElements>
-  <a:objectDefaults>
-    <a:lnDef>
-      <a:spPr/>
-      <a:bodyPr/>
-      <a:lstStyle/>
-      <a:style>
-        <a:lnRef idx="2">
-          <a:schemeClr val="accent1"/>
-        </a:lnRef>
-        <a:fillRef idx="0">
-          <a:schemeClr val="accent1"/>
-        </a:fillRef>
-        <a:effectRef idx="1">
-          <a:schemeClr val="accent1"/>
-        </a:effectRef>
-        <a:fontRef idx="minor">
-          <a:schemeClr val="tx1"/>
-        </a:fontRef>
-      </a:style>
-    </a:lnDef>
-  </a:objectDefaults>
-  <a:extraClrSchemeLst/>
-  <a:extLst>
-    <a:ext uri="{05A4C25C-085E-4340-85A3-A5531E510DB2}">
-      <thm15:themeFamily xmlns:thm15="http://schemas.microsoft.com/office/thememl/2012/main" name="Office Theme" id="{2E142A2C-CD16-42D6-873A-C26D2A0506FA}" vid="{1BDDFF52-6CD6-40A5-AB3C-68EB2F1E4D0A}"/>
-    </a:ext>
-  </a:extLst>
-</a:theme>
 </file>
</xml_diff>